<commit_message>
feat(night-r4): integrate 10 agent branches — 5 tools (Capability/Ambition/Focus/Narrative/Risk → 19/19) + RAID handoff, maturity path N→N+1 (DRD/SIRI/ADMA), finance O4.5-4.7 (WACC/statements/post-mortem), 3 doc-editors on Editor Shell, 9 hubs c.* tokens, premium PPTX/XLSX stylers, generic Tools→Inicjatywy handoff, M15↔M16 reconciliation + M06 routing fix
Co-Authored-By: Claude Opus 4.8 <noreply@anthropic.com>
</commit_message>
<xml_diff>
--- a/docs/qa/deliverables/runs/ATELIER-DECK.pptx
+++ b/docs/qa/deliverables/runs/ATELIER-DECK.pptx
@@ -18,9 +18,10 @@
     <p:sldId id="266" r:id="rId12"/>
     <p:sldId id="267" r:id="rId13"/>
     <p:sldId id="268" r:id="rId14"/>
+    <p:sldId id="269" r:id="rId15"/>
   </p:sldIdLst>
   <p:notesMasterIdLst>
-    <p:notesMasterId r:id="rId15"/>
+    <p:notesMasterId r:id="rId16"/>
   </p:notesMasterIdLst>
   <p:sldSz cx="9144000" cy="5143500"/>
   <p:notesSz cx="5143500" cy="9144000"/>
@@ -874,8 +875,7 @@
           <a:p>
             <a:r>
               <a:rPr lang="en-US" dirty="0"/>
-              <a:t>• 1. Line 3 Digital Twin — operational value, visible demo
-• 5-7. OT Cyber · Data Governance · Partner ActivationA portfolio can hold 20 initiatives, but executive attention should prove the operating model on the handful with clear value, named owners and a strong KPI path. Sequencing follows the priority matrix.</a:t>
+              <a:t>Atelier is genuinely strong on operations and ESG credentials, but district procurement, COPPA posture, AI use-case governance and origin-aware sourcing become contractual deal-blockers before US scale is a safe bet.</a:t>
             </a:r>
             <a:endParaRPr lang="en-US" dirty="0"/>
           </a:p>
@@ -963,10 +963,8 @@
           <a:p>
             <a:r>
               <a:rPr lang="en-US" dirty="0"/>
-              <a:t>• Week 1 — confirm Wave 1 scope, owners and KPI baselines
-• Week 2 — run first control tower; prototype 3 signal systems
-• Week 3 — validate financials with confidence-banded value view
-• Week 4 — executive review: scale, adjust or stopEvidence is decision-grade for prioritization. Start the right 30-day actions now while assigning data owners to close baseline gaps in parallel — do not wait for a full maturity audit.</a:t>
+              <a:t>• 1. Line 3 Digital Twin — operational value, visible demo
+• 5-7. OT Cyber · Data Governance · Partner ActivationA portfolio can hold 20 initiatives, but executive attention should prove the operating model on the handful with clear value, named owners and a strong KPI path. Sequencing follows the priority matrix.</a:t>
             </a:r>
             <a:endParaRPr lang="en-US" dirty="0"/>
           </a:p>
@@ -1054,9 +1052,7 @@
           <a:p>
             <a:r>
               <a:rPr lang="en-US" dirty="0"/>
-              <a:t>• Every Wave 1 initiative expressible as a sub-thesis of one story
-• Adoption KPIs at role level protect 1.5-2.5 M EUR Wave 1 value
-• US buyers, districts and partners rehearse one message backAdopt one thesis — Atelier runs a governed digital transformation turning distributed digital signals into reliable enterprise decisions, with measurable value in operations, digital revenue quality and enterprise risk.</a:t>
+              <a:t/>
             </a:r>
             <a:endParaRPr lang="en-US" dirty="0"/>
           </a:p>
@@ -1144,7 +1140,9 @@
           <a:p>
             <a:r>
               <a:rPr lang="en-US" dirty="0"/>
-              <a:t/>
+              <a:t>• Every Wave 1 initiative expressible as a sub-thesis of one story
+• Adoption KPIs at role level protect 1.5-2.5 M EUR Wave 1 value
+• US buyers, districts and partners rehearse one message backAdopt one thesis — Atelier runs a governed digital transformation turning distributed digital signals into reliable enterprise decisions, with measurable value in operations, digital revenue quality and enterprise risk.</a:t>
             </a:r>
             <a:endParaRPr lang="en-US" dirty="0"/>
           </a:p>
@@ -1168,6 +1166,94 @@
             <a:fld id="{F7021451-1387-4CA6-816F-3879F97B5CBC}" type="slidenum">
               <a:rPr lang="en-US"/>
               <a:t>13</a:t>
+            </a:fld>
+            <a:endParaRPr lang="en-US"/>
+          </a:p>
+        </p:txBody>
+      </p:sp>
+    </p:spTree>
+    <p:extLst>
+      <p:ext uri="{BB962C8B-B14F-4D97-AF65-F5344CB8AC3E}">
+        <p14:creationId xmlns:p14="http://schemas.microsoft.com/office/powerpoint/2010/main" val="1024086991"/>
+      </p:ext>
+    </p:extLst>
+  </p:cSld>
+  <p:clrMapOvr>
+    <a:masterClrMapping/>
+  </p:clrMapOvr>
+</p:notes>
+</file>
+
+<file path=ppt/notesSlides/notesSlide14.xml><?xml version="1.0" encoding="utf-8"?>
+<p:notes xmlns:a="http://schemas.openxmlformats.org/drawingml/2006/main" xmlns:r="http://schemas.openxmlformats.org/officeDocument/2006/relationships" xmlns:p="http://schemas.openxmlformats.org/presentationml/2006/main">
+  <p:cSld>
+    <p:spTree>
+      <p:nvGrpSpPr>
+        <p:cNvPr id="1" name=""/>
+        <p:cNvGrpSpPr/>
+        <p:nvPr/>
+      </p:nvGrpSpPr>
+      <p:grpSpPr>
+        <a:xfrm>
+          <a:off x="0" y="0"/>
+          <a:ext cx="0" cy="0"/>
+          <a:chOff x="0" y="0"/>
+          <a:chExt cx="0" cy="0"/>
+        </a:xfrm>
+      </p:grpSpPr>
+      <p:sp>
+        <p:nvSpPr>
+          <p:cNvPr id="2" name="Slide Image Placeholder 1"/>
+          <p:cNvSpPr>
+            <a:spLocks noGrp="1" noRot="1" noChangeAspect="1"/>
+          </p:cNvSpPr>
+          <p:nvPr>
+            <p:ph type="sldImg"/>
+          </p:nvPr>
+        </p:nvSpPr>
+        <p:spPr/>
+      </p:sp>
+      <p:sp>
+        <p:nvSpPr>
+          <p:cNvPr id="3" name="Notes Placeholder 2"/>
+          <p:cNvSpPr>
+            <a:spLocks noGrp="1"/>
+          </p:cNvSpPr>
+          <p:nvPr>
+            <p:ph type="body" idx="1"/>
+          </p:nvPr>
+        </p:nvSpPr>
+        <p:spPr/>
+        <p:txBody>
+          <a:bodyPr/>
+          <a:lstStyle/>
+          <a:p>
+            <a:r>
+              <a:rPr lang="en-US" dirty="0"/>
+              <a:t/>
+            </a:r>
+            <a:endParaRPr lang="en-US" dirty="0"/>
+          </a:p>
+        </p:txBody>
+      </p:sp>
+      <p:sp>
+        <p:nvSpPr>
+          <p:cNvPr id="4" name="Slide Number Placeholder 3"/>
+          <p:cNvSpPr>
+            <a:spLocks noGrp="1"/>
+          </p:cNvSpPr>
+          <p:nvPr>
+            <p:ph type="sldNum" sz="quarter" idx="10"/>
+          </p:nvPr>
+        </p:nvSpPr>
+        <p:spPr/>
+        <p:txBody>
+          <a:bodyPr/>
+          <a:lstStyle/>
+          <a:p>
+            <a:fld id="{F7021451-1387-4CA6-816F-3879F97B5CBC}" type="slidenum">
+              <a:rPr lang="en-US"/>
+              <a:t>14</a:t>
             </a:fld>
             <a:endParaRPr lang="en-US"/>
           </a:p>
@@ -1322,8 +1408,7 @@
           <a:p>
             <a:r>
               <a:rPr lang="en-US" dirty="0"/>
-              <a:t>• Data definitions vary — portfolio progress is not comparable
-• Pilots lack scale gates — real gains stay unrepeatablePlant, finance, product, customer success and partners describe one shared gap from different angles: enough data to act earlier, not enough governance discipline to turn data into consistent decisions.</a:t>
+              <a:t/>
             </a:r>
             <a:endParaRPr lang="en-US" dirty="0"/>
           </a:p>
@@ -1499,7 +1584,7 @@
           <a:p>
             <a:r>
               <a:rPr lang="en-US" dirty="0"/>
-              <a:t/>
+              <a:t>Four numbers frame the mandate: a deep evidence base, a large but concentrated value pool, and a renewal gap that alone protects the biggest single pool.</a:t>
             </a:r>
             <a:endParaRPr lang="en-US" dirty="0"/>
           </a:p>
@@ -1587,8 +1672,7 @@
           <a:p>
             <a:r>
               <a:rPr lang="en-US" dirty="0"/>
-              <a:t>• Event taxonomy + alert routing + action protocol + learning capture
-• Fund Digital Twin as an operating system, not a dashboardAlerts exist; routing, classification and action protocols are inconsistent across shifts. A 20-30 min event-to-response lag leaks 0.8-1.2 M EUR/yr on Line 3 before changeover and downtime gains are layered in.</a:t>
+              <a:t/>
             </a:r>
             <a:endParaRPr lang="en-US" dirty="0"/>
           </a:p>
@@ -1676,7 +1760,7 @@
           <a:p>
             <a:r>
               <a:rPr lang="en-US" dirty="0"/>
-              <a:t>Activation, usage, support and partner signals live in separate views; risk surfaces only after escalation. Moving gross renewal from 76-80% toward the 88-92% top-quartile reference protects 4-6 M EUR ARR.</a:t>
+              <a:t/>
             </a:r>
             <a:endParaRPr lang="en-US" dirty="0"/>
           </a:p>
@@ -1764,8 +1848,7 @@
           <a:p>
             <a:r>
               <a:rPr lang="en-US" dirty="0"/>
-              <a:t>• Decision required: fund top-25 metric ownership and lineage in Wave 1
-• Definitions, ownership, lineage, quality SLAs — the boring workOEE, defect recurrence, supplier risk, renewal risk, partner activation and roadmap value all need one source of truth. Inconsistent definitions drag portfolio productivity 8-12% and raise US audit cost as scale grows.</a:t>
+              <a:t/>
             </a:r>
             <a:endParaRPr lang="en-US" dirty="0"/>
           </a:p>
@@ -1853,10 +1936,7 @@
           <a:p>
             <a:r>
               <a:rPr lang="en-US" dirty="0"/>
-              <a:t>• District &amp; GPO contract readiness — Partial, close before scale
-• COPPA / US state privacy posture — Needs evidence
-• AI use-case governance for child-facing AI — Needs evidence
-• ESG &amp; supply-chain traceability — Yes, package as buyer assetAtelier is genuinely strong on operations and ESG credentials, but district procurement, COPPA posture, AI use-case governance and origin-aware sourcing become contractual deal-blockers before US scale is a safe bet.</a:t>
+              <a:t/>
             </a:r>
             <a:endParaRPr lang="en-US" dirty="0"/>
           </a:p>
@@ -2572,7 +2652,7 @@
                 <a:ea typeface="Merriweather" pitchFamily="34" charset="-122"/>
                 <a:cs typeface="Merriweather" pitchFamily="34" charset="-120"/>
               </a:rPr>
-              <a:t>Wave 1 focuses executive attention on seven initiatives, not twenty</a:t>
+              <a:t>US expansion raises the bar: data, AI, partner and tariff readiness need evidence</a:t>
             </a:r>
             <a:endParaRPr lang="en-US" sz="3000" dirty="0"/>
           </a:p>
@@ -2739,7 +2819,7 @@
                 <a:ea typeface="Inter" pitchFamily="34" charset="-122"/>
                 <a:cs typeface="Inter" pitchFamily="34" charset="-120"/>
               </a:rPr>
-              <a:t>ROADMAP</a:t>
+              <a:t>MARKET</a:t>
             </a:r>
             <a:endParaRPr lang="en-US" sz="700" dirty="0"/>
           </a:p>
@@ -2747,14 +2827,105 @@
       </p:sp>
       <p:sp>
         <p:nvSpPr>
-          <p:cNvPr id="9" name="Text 7"/>
+          <p:cNvPr id="9" name="Shape 7"/>
           <p:cNvSpPr/>
           <p:nvPr/>
         </p:nvSpPr>
         <p:spPr>
           <a:xfrm>
             <a:off x="548640" y="1554480"/>
-            <a:ext cx="8046720" cy="3017520"/>
+            <a:ext cx="3840480" cy="3063240"/>
+          </a:xfrm>
+          <a:prstGeom prst="rect">
+            <a:avLst/>
+          </a:prstGeom>
+          <a:solidFill>
+            <a:srgbClr val="F5F8FC"/>
+          </a:solidFill>
+          <a:ln w="12700">
+            <a:solidFill>
+              <a:srgbClr val="E3E7EE"/>
+            </a:solidFill>
+            <a:prstDash val="solid"/>
+          </a:ln>
+        </p:spPr>
+      </p:sp>
+      <p:sp>
+        <p:nvSpPr>
+          <p:cNvPr id="10" name="Shape 8"/>
+          <p:cNvSpPr/>
+          <p:nvPr/>
+        </p:nvSpPr>
+        <p:spPr>
+          <a:xfrm>
+            <a:off x="548640" y="1554480"/>
+            <a:ext cx="3840480" cy="457200"/>
+          </a:xfrm>
+          <a:prstGeom prst="rect">
+            <a:avLst/>
+          </a:prstGeom>
+          <a:solidFill>
+            <a:srgbClr val="0C447C"/>
+          </a:solidFill>
+          <a:ln w="12700">
+            <a:solidFill>
+              <a:srgbClr val="0C447C"/>
+            </a:solidFill>
+            <a:prstDash val="solid"/>
+          </a:ln>
+        </p:spPr>
+      </p:sp>
+      <p:sp>
+        <p:nvSpPr>
+          <p:cNvPr id="11" name="Text 9"/>
+          <p:cNvSpPr/>
+          <p:nvPr/>
+        </p:nvSpPr>
+        <p:spPr>
+          <a:xfrm>
+            <a:off x="713232" y="1554480"/>
+            <a:ext cx="3511296" cy="457200"/>
+          </a:xfrm>
+          <a:prstGeom prst="rect">
+            <a:avLst/>
+          </a:prstGeom>
+          <a:noFill/>
+          <a:ln/>
+        </p:spPr>
+        <p:txBody>
+          <a:bodyPr wrap="square" rtlCol="0" anchor="ctr">
+            <a:normAutofit/>
+          </a:bodyPr>
+          <a:lstStyle/>
+          <a:p>
+            <a:pPr algn="l" indent="0" marL="0">
+              <a:buNone/>
+            </a:pPr>
+            <a:r>
+              <a:rPr lang="en-US" sz="1400" b="1" dirty="0">
+                <a:solidFill>
+                  <a:srgbClr val="FFFFFF"/>
+                </a:solidFill>
+                <a:latin typeface="Merriweather" pitchFamily="34" charset="0"/>
+                <a:ea typeface="Merriweather" pitchFamily="34" charset="-122"/>
+                <a:cs typeface="Merriweather" pitchFamily="34" charset="-120"/>
+              </a:rPr>
+              <a:t>Already an asset</a:t>
+            </a:r>
+            <a:endParaRPr lang="en-US" sz="1400" dirty="0"/>
+          </a:p>
+        </p:txBody>
+      </p:sp>
+      <p:sp>
+        <p:nvSpPr>
+          <p:cNvPr id="12" name="Text 10"/>
+          <p:cNvSpPr/>
+          <p:nvPr/>
+        </p:nvSpPr>
+        <p:spPr>
+          <a:xfrm>
+            <a:off x="713232" y="2176272"/>
+            <a:ext cx="3511296" cy="2286000"/>
           </a:xfrm>
           <a:prstGeom prst="rect">
             <a:avLst/>
@@ -2768,15 +2939,15 @@
           </a:bodyPr>
           <a:lstStyle/>
           <a:p>
-            <a:pPr algn="l" marL="228600" indent="-228600">
+            <a:pPr algn="l" marL="203200" indent="-203200">
               <a:spcAft>
-                <a:spcPts val="800"/>
+                <a:spcPts val="700"/>
               </a:spcAft>
               <a:buSzPct val="100000"/>
               <a:buChar char="▪"/>
             </a:pPr>
             <a:r>
-              <a:rPr lang="en-US" sz="2000" dirty="0">
+              <a:rPr lang="en-US" sz="1300" dirty="0">
                 <a:solidFill>
                   <a:srgbClr val="2C2C2A"/>
                 </a:solidFill>
@@ -2784,17 +2955,17 @@
                 <a:ea typeface="Inter" pitchFamily="34" charset="-122"/>
                 <a:cs typeface="Inter" pitchFamily="34" charset="-120"/>
               </a:rPr>
-              <a:t>1. Line 3 Digital Twin — operational value,…</a:t>
-            </a:r>
-            <a:pPr algn="l" marL="228600" indent="-228600">
+              <a:t>ESG &amp; supply-chain traceability — package as buyer proof</a:t>
+            </a:r>
+            <a:pPr algn="l" marL="203200" indent="-203200">
               <a:spcAft>
-                <a:spcPts val="800"/>
+                <a:spcPts val="700"/>
               </a:spcAft>
               <a:buSzPct val="100000"/>
               <a:buChar char="▪"/>
             </a:pPr>
             <a:r>
-              <a:rPr lang="en-US" sz="2000" dirty="0">
+              <a:rPr lang="en-US" sz="1300" dirty="0">
                 <a:solidFill>
                   <a:srgbClr val="2C2C2A"/>
                 </a:solidFill>
@@ -2802,17 +2973,17 @@
                 <a:ea typeface="Inter" pitchFamily="34" charset="-122"/>
                 <a:cs typeface="Inter" pitchFamily="34" charset="-120"/>
               </a:rPr>
-              <a:t>2. Procurement Control Tower — resilience and margin</a:t>
-            </a:r>
-            <a:pPr algn="l" marL="228600" indent="-228600">
+              <a:t>Operations &amp; OEE credentials — genuine strength</a:t>
+            </a:r>
+            <a:pPr algn="l" marL="203200" indent="-203200">
               <a:spcAft>
-                <a:spcPts val="800"/>
+                <a:spcPts val="700"/>
               </a:spcAft>
               <a:buSzPct val="100000"/>
               <a:buChar char="▪"/>
             </a:pPr>
             <a:r>
-              <a:rPr lang="en-US" sz="2000" dirty="0">
+              <a:rPr lang="en-US" sz="1300" dirty="0">
                 <a:solidFill>
                   <a:srgbClr val="2C2C2A"/>
                 </a:solidFill>
@@ -2820,17 +2991,135 @@
                 <a:ea typeface="Inter" pitchFamily="34" charset="-122"/>
                 <a:cs typeface="Inter" pitchFamily="34" charset="-120"/>
               </a:rPr>
-              <a:t>3. Renewal-Risk Action System — digital revenue quality</a:t>
-            </a:r>
-            <a:pPr algn="l" marL="228600" indent="-228600">
+              <a:t>Learning-outcome usage data — partial, extendable</a:t>
+            </a:r>
+            <a:endParaRPr lang="en-US" sz="1300" dirty="0"/>
+          </a:p>
+        </p:txBody>
+      </p:sp>
+      <p:sp>
+        <p:nvSpPr>
+          <p:cNvPr id="13" name="Shape 11"/>
+          <p:cNvSpPr/>
+          <p:nvPr/>
+        </p:nvSpPr>
+        <p:spPr>
+          <a:xfrm>
+            <a:off x="4754880" y="1554480"/>
+            <a:ext cx="3840480" cy="3063240"/>
+          </a:xfrm>
+          <a:prstGeom prst="rect">
+            <a:avLst/>
+          </a:prstGeom>
+          <a:solidFill>
+            <a:srgbClr val="F2F9F6"/>
+          </a:solidFill>
+          <a:ln w="12700">
+            <a:solidFill>
+              <a:srgbClr val="E3E7EE"/>
+            </a:solidFill>
+            <a:prstDash val="solid"/>
+          </a:ln>
+        </p:spPr>
+      </p:sp>
+      <p:sp>
+        <p:nvSpPr>
+          <p:cNvPr id="14" name="Shape 12"/>
+          <p:cNvSpPr/>
+          <p:nvPr/>
+        </p:nvSpPr>
+        <p:spPr>
+          <a:xfrm>
+            <a:off x="4754880" y="1554480"/>
+            <a:ext cx="3840480" cy="457200"/>
+          </a:xfrm>
+          <a:prstGeom prst="rect">
+            <a:avLst/>
+          </a:prstGeom>
+          <a:solidFill>
+            <a:srgbClr val="1D9E75"/>
+          </a:solidFill>
+          <a:ln w="12700">
+            <a:solidFill>
+              <a:srgbClr val="1D9E75"/>
+            </a:solidFill>
+            <a:prstDash val="solid"/>
+          </a:ln>
+        </p:spPr>
+      </p:sp>
+      <p:sp>
+        <p:nvSpPr>
+          <p:cNvPr id="15" name="Text 13"/>
+          <p:cNvSpPr/>
+          <p:nvPr/>
+        </p:nvSpPr>
+        <p:spPr>
+          <a:xfrm>
+            <a:off x="4919472" y="1554480"/>
+            <a:ext cx="3511296" cy="457200"/>
+          </a:xfrm>
+          <a:prstGeom prst="rect">
+            <a:avLst/>
+          </a:prstGeom>
+          <a:noFill/>
+          <a:ln/>
+        </p:spPr>
+        <p:txBody>
+          <a:bodyPr wrap="square" rtlCol="0" anchor="ctr">
+            <a:normAutofit/>
+          </a:bodyPr>
+          <a:lstStyle/>
+          <a:p>
+            <a:pPr algn="l" indent="0" marL="0">
+              <a:buNone/>
+            </a:pPr>
+            <a:r>
+              <a:rPr lang="en-US" sz="1400" b="1" dirty="0">
+                <a:solidFill>
+                  <a:srgbClr val="FFFFFF"/>
+                </a:solidFill>
+                <a:latin typeface="Merriweather" pitchFamily="34" charset="0"/>
+                <a:ea typeface="Merriweather" pitchFamily="34" charset="-122"/>
+                <a:cs typeface="Merriweather" pitchFamily="34" charset="-120"/>
+              </a:rPr>
+              <a:t>Close before US scale</a:t>
+            </a:r>
+            <a:endParaRPr lang="en-US" sz="1400" dirty="0"/>
+          </a:p>
+        </p:txBody>
+      </p:sp>
+      <p:sp>
+        <p:nvSpPr>
+          <p:cNvPr id="16" name="Text 14"/>
+          <p:cNvSpPr/>
+          <p:nvPr/>
+        </p:nvSpPr>
+        <p:spPr>
+          <a:xfrm>
+            <a:off x="4919472" y="2176272"/>
+            <a:ext cx="3511296" cy="2286000"/>
+          </a:xfrm>
+          <a:prstGeom prst="rect">
+            <a:avLst/>
+          </a:prstGeom>
+          <a:noFill/>
+          <a:ln/>
+        </p:spPr>
+        <p:txBody>
+          <a:bodyPr wrap="square" rtlCol="0" anchor="t">
+            <a:normAutofit/>
+          </a:bodyPr>
+          <a:lstStyle/>
+          <a:p>
+            <a:pPr algn="l" marL="203200" indent="-203200">
               <a:spcAft>
-                <a:spcPts val="800"/>
+                <a:spcPts val="700"/>
               </a:spcAft>
               <a:buSzPct val="100000"/>
               <a:buChar char="▪"/>
             </a:pPr>
             <a:r>
-              <a:rPr lang="en-US" sz="2000" dirty="0">
+              <a:rPr lang="en-US" sz="1300" dirty="0">
                 <a:solidFill>
                   <a:srgbClr val="2C2C2A"/>
                 </a:solidFill>
@@ -2838,17 +3127,17 @@
                 <a:ea typeface="Inter" pitchFamily="34" charset="-122"/>
                 <a:cs typeface="Inter" pitchFamily="34" charset="-120"/>
               </a:rPr>
-              <a:t>4. Closed-Loop Quality Cockpit — prevents quality debt</a:t>
-            </a:r>
-            <a:pPr algn="l" marL="228600" indent="-228600">
+              <a:t>District &amp; GPO contract readiness — standardize pack</a:t>
+            </a:r>
+            <a:pPr algn="l" marL="203200" indent="-203200">
               <a:spcAft>
-                <a:spcPts val="800"/>
+                <a:spcPts val="700"/>
               </a:spcAft>
               <a:buSzPct val="100000"/>
               <a:buChar char="▪"/>
             </a:pPr>
             <a:r>
-              <a:rPr lang="en-US" sz="2000" dirty="0">
+              <a:rPr lang="en-US" sz="1300" dirty="0">
                 <a:solidFill>
                   <a:srgbClr val="2C2C2A"/>
                 </a:solidFill>
@@ -2856,9 +3145,45 @@
                 <a:ea typeface="Inter" pitchFamily="34" charset="-122"/>
                 <a:cs typeface="Inter" pitchFamily="34" charset="-120"/>
               </a:rPr>
-              <a:t>5-7. OT Cyber · Data Governance · Partner…</a:t>
-            </a:r>
-            <a:endParaRPr lang="en-US" sz="2000" dirty="0"/>
+              <a:t>COPPA / US state privacy — document child-data flows</a:t>
+            </a:r>
+            <a:pPr algn="l" marL="203200" indent="-203200">
+              <a:spcAft>
+                <a:spcPts val="700"/>
+              </a:spcAft>
+              <a:buSzPct val="100000"/>
+              <a:buChar char="▪"/>
+            </a:pPr>
+            <a:r>
+              <a:rPr lang="en-US" sz="1300" dirty="0">
+                <a:solidFill>
+                  <a:srgbClr val="2C2C2A"/>
+                </a:solidFill>
+                <a:latin typeface="Inter" pitchFamily="34" charset="0"/>
+                <a:ea typeface="Inter" pitchFamily="34" charset="-122"/>
+                <a:cs typeface="Inter" pitchFamily="34" charset="-120"/>
+              </a:rPr>
+              <a:t>AI use-case governance — approved-use registry + audit</a:t>
+            </a:r>
+            <a:pPr algn="l" marL="203200" indent="-203200">
+              <a:spcAft>
+                <a:spcPts val="700"/>
+              </a:spcAft>
+              <a:buSzPct val="100000"/>
+              <a:buChar char="▪"/>
+            </a:pPr>
+            <a:r>
+              <a:rPr lang="en-US" sz="1300" dirty="0">
+                <a:solidFill>
+                  <a:srgbClr val="2C2C2A"/>
+                </a:solidFill>
+                <a:latin typeface="Inter" pitchFamily="34" charset="0"/>
+                <a:ea typeface="Inter" pitchFamily="34" charset="-122"/>
+                <a:cs typeface="Inter" pitchFamily="34" charset="-120"/>
+              </a:rPr>
+              <a:t>Tariff &amp; origin-aware procurement — scenario model</a:t>
+            </a:r>
+            <a:endParaRPr lang="en-US" sz="1300" dirty="0"/>
           </a:p>
         </p:txBody>
       </p:sp>
@@ -2957,7 +3282,7 @@
                 <a:ea typeface="Merriweather" pitchFamily="34" charset="-122"/>
                 <a:cs typeface="Merriweather" pitchFamily="34" charset="-120"/>
               </a:rPr>
-              <a:t>What to do first: launch Wave 1 now and reposition the PMO as a control tower</a:t>
+              <a:t>Wave 1 focuses executive attention on seven initiatives, not twenty</a:t>
             </a:r>
             <a:endParaRPr lang="en-US" sz="3000" dirty="0"/>
           </a:p>
@@ -3124,7 +3449,7 @@
                 <a:ea typeface="Inter" pitchFamily="34" charset="-122"/>
                 <a:cs typeface="Inter" pitchFamily="34" charset="-120"/>
               </a:rPr>
-              <a:t>ASK</a:t>
+              <a:t>ROADMAP</a:t>
             </a:r>
             <a:endParaRPr lang="en-US" sz="700" dirty="0"/>
           </a:p>
@@ -3169,7 +3494,7 @@
                 <a:ea typeface="Inter" pitchFamily="34" charset="-122"/>
                 <a:cs typeface="Inter" pitchFamily="34" charset="-120"/>
               </a:rPr>
-              <a:t>Week 1 — confirm Wave 1 scope, owners…</a:t>
+              <a:t>1. Line 3 Digital Twin — operational value,…</a:t>
             </a:r>
             <a:pPr algn="l" marL="228600" indent="-228600">
               <a:spcAft>
@@ -3187,7 +3512,7 @@
                 <a:ea typeface="Inter" pitchFamily="34" charset="-122"/>
                 <a:cs typeface="Inter" pitchFamily="34" charset="-120"/>
               </a:rPr>
-              <a:t>Week 2 — run first control tower; prototype…</a:t>
+              <a:t>2. Procurement Control Tower — resilience and margin</a:t>
             </a:r>
             <a:pPr algn="l" marL="228600" indent="-228600">
               <a:spcAft>
@@ -3205,7 +3530,7 @@
                 <a:ea typeface="Inter" pitchFamily="34" charset="-122"/>
                 <a:cs typeface="Inter" pitchFamily="34" charset="-120"/>
               </a:rPr>
-              <a:t>Week 3 — validate financials with confidence-banded value…</a:t>
+              <a:t>3. Renewal-Risk Action System — digital revenue quality</a:t>
             </a:r>
             <a:pPr algn="l" marL="228600" indent="-228600">
               <a:spcAft>
@@ -3223,7 +3548,7 @@
                 <a:ea typeface="Inter" pitchFamily="34" charset="-122"/>
                 <a:cs typeface="Inter" pitchFamily="34" charset="-120"/>
               </a:rPr>
-              <a:t>Week 4 — executive review: scale, adjust or…</a:t>
+              <a:t>4. Closed-Loop Quality Cockpit — prevents quality debt</a:t>
             </a:r>
             <a:pPr algn="l" marL="228600" indent="-228600">
               <a:spcAft>
@@ -3241,7 +3566,7 @@
                 <a:ea typeface="Inter" pitchFamily="34" charset="-122"/>
                 <a:cs typeface="Inter" pitchFamily="34" charset="-120"/>
               </a:rPr>
-              <a:t>Require confidence-banded value cases before Gate 2 funding</a:t>
+              <a:t>5-7. OT Cyber · Data Governance · Partner…</a:t>
             </a:r>
             <a:endParaRPr lang="en-US" sz="2000" dirty="0"/>
           </a:p>
@@ -3342,7 +3667,7 @@
                 <a:ea typeface="Merriweather" pitchFamily="34" charset="-122"/>
                 <a:cs typeface="Merriweather" pitchFamily="34" charset="-120"/>
               </a:rPr>
-              <a:t>What to expect: one board narrative that converts digital signals into governed value</a:t>
+              <a:t>What to do first: launch Wave 1 now and reposition the PMO as a control tower</a:t>
             </a:r>
             <a:endParaRPr lang="en-US" sz="3000" dirty="0"/>
           </a:p>
@@ -3457,8 +3782,8 @@
         </p:nvSpPr>
         <p:spPr>
           <a:xfrm>
-            <a:off x="7545629" y="164592"/>
-            <a:ext cx="1232611" cy="237744"/>
+            <a:off x="7955280" y="164592"/>
+            <a:ext cx="822960" cy="237744"/>
           </a:xfrm>
           <a:prstGeom prst="roundRect">
             <a:avLst>
@@ -3484,8 +3809,8 @@
         </p:nvSpPr>
         <p:spPr>
           <a:xfrm>
-            <a:off x="7545629" y="164592"/>
-            <a:ext cx="1232611" cy="237744"/>
+            <a:off x="7955280" y="164592"/>
+            <a:ext cx="822960" cy="237744"/>
           </a:xfrm>
           <a:prstGeom prst="rect">
             <a:avLst/>
@@ -3509,7 +3834,7 @@
                 <a:ea typeface="Inter" pitchFamily="34" charset="-122"/>
                 <a:cs typeface="Inter" pitchFamily="34" charset="-120"/>
               </a:rPr>
-              <a:t>UNIT ECONOMICS</a:t>
+              <a:t>ASK</a:t>
             </a:r>
             <a:endParaRPr lang="en-US" sz="700" dirty="0"/>
           </a:p>
@@ -3517,14 +3842,81 @@
       </p:sp>
       <p:sp>
         <p:nvSpPr>
-          <p:cNvPr id="9" name="Text 7"/>
-          <p:cNvSpPr/>
-          <p:nvPr/>
-        </p:nvSpPr>
-        <p:spPr>
-          <a:xfrm>
-            <a:off x="548640" y="1554480"/>
-            <a:ext cx="8046720" cy="3017520"/>
+          <p:cNvPr id="9" name="Shape 7"/>
+          <p:cNvSpPr/>
+          <p:nvPr/>
+        </p:nvSpPr>
+        <p:spPr>
+          <a:xfrm>
+            <a:off x="548640" y="1600200"/>
+            <a:ext cx="73152" cy="822960"/>
+          </a:xfrm>
+          <a:prstGeom prst="rect">
+            <a:avLst/>
+          </a:prstGeom>
+          <a:solidFill>
+            <a:srgbClr val="1D9E75"/>
+          </a:solidFill>
+          <a:ln w="12700">
+            <a:solidFill>
+              <a:srgbClr val="1D9E75"/>
+            </a:solidFill>
+            <a:prstDash val="solid"/>
+          </a:ln>
+        </p:spPr>
+      </p:sp>
+      <p:sp>
+        <p:nvSpPr>
+          <p:cNvPr id="10" name="Text 8"/>
+          <p:cNvSpPr/>
+          <p:nvPr/>
+        </p:nvSpPr>
+        <p:spPr>
+          <a:xfrm>
+            <a:off x="749808" y="1554480"/>
+            <a:ext cx="3977640" cy="3063240"/>
+          </a:xfrm>
+          <a:prstGeom prst="rect">
+            <a:avLst/>
+          </a:prstGeom>
+          <a:noFill/>
+          <a:ln/>
+        </p:spPr>
+        <p:txBody>
+          <a:bodyPr wrap="square" rtlCol="0" anchor="t"/>
+          <a:lstStyle/>
+          <a:p>
+            <a:pPr algn="l" indent="0" marL="0">
+              <a:lnSpc>
+                <a:spcPct val="102000"/>
+              </a:lnSpc>
+              <a:buNone/>
+            </a:pPr>
+            <a:r>
+              <a:rPr lang="en-US" sz="2400" b="1" dirty="0">
+                <a:solidFill>
+                  <a:srgbClr val="0C447C"/>
+                </a:solidFill>
+                <a:latin typeface="Merriweather" pitchFamily="34" charset="0"/>
+                <a:ea typeface="Merriweather" pitchFamily="34" charset="-122"/>
+                <a:cs typeface="Merriweather" pitchFamily="34" charset="-120"/>
+              </a:rPr>
+              <a:t>Evidence is decision-grade for prioritization. Start the right 30-day actions now while assigning data owners to close baseline gaps in parallel — do not wait for a full maturity audit.</a:t>
+            </a:r>
+            <a:endParaRPr lang="en-US" sz="2400" dirty="0"/>
+          </a:p>
+        </p:txBody>
+      </p:sp>
+      <p:sp>
+        <p:nvSpPr>
+          <p:cNvPr id="11" name="Text 9"/>
+          <p:cNvSpPr/>
+          <p:nvPr/>
+        </p:nvSpPr>
+        <p:spPr>
+          <a:xfrm>
+            <a:off x="5212080" y="1554480"/>
+            <a:ext cx="3383280" cy="3063240"/>
           </a:xfrm>
           <a:prstGeom prst="rect">
             <a:avLst/>
@@ -3538,7 +3930,7 @@
           </a:bodyPr>
           <a:lstStyle/>
           <a:p>
-            <a:pPr algn="l" marL="228600" indent="-228600">
+            <a:pPr algn="l" marL="203200" indent="-203200">
               <a:spcAft>
                 <a:spcPts val="800"/>
               </a:spcAft>
@@ -3546,7 +3938,7 @@
               <a:buChar char="▪"/>
             </a:pPr>
             <a:r>
-              <a:rPr lang="en-US" sz="2000" dirty="0">
+              <a:rPr lang="en-US" sz="1700" dirty="0">
                 <a:solidFill>
                   <a:srgbClr val="2C2C2A"/>
                 </a:solidFill>
@@ -3554,9 +3946,9 @@
                 <a:ea typeface="Inter" pitchFamily="34" charset="-122"/>
                 <a:cs typeface="Inter" pitchFamily="34" charset="-120"/>
               </a:rPr>
-              <a:t>Every Wave 1 initiative expressible as a sub-thesis…</a:t>
-            </a:r>
-            <a:pPr algn="l" marL="228600" indent="-228600">
+              <a:t>Week 1 — confirm Wave 1 scope, owners and KPI baselines</a:t>
+            </a:r>
+            <a:pPr algn="l" marL="203200" indent="-203200">
               <a:spcAft>
                 <a:spcPts val="800"/>
               </a:spcAft>
@@ -3564,7 +3956,7 @@
               <a:buChar char="▪"/>
             </a:pPr>
             <a:r>
-              <a:rPr lang="en-US" sz="2000" dirty="0">
+              <a:rPr lang="en-US" sz="1700" dirty="0">
                 <a:solidFill>
                   <a:srgbClr val="2C2C2A"/>
                 </a:solidFill>
@@ -3572,9 +3964,9 @@
                 <a:ea typeface="Inter" pitchFamily="34" charset="-122"/>
                 <a:cs typeface="Inter" pitchFamily="34" charset="-120"/>
               </a:rPr>
-              <a:t>Decision ledger ends reopened decisions and lost momentum</a:t>
-            </a:r>
-            <a:pPr algn="l" marL="228600" indent="-228600">
+              <a:t>Week 2 — run first control tower; prototype 3 signal systems</a:t>
+            </a:r>
+            <a:pPr algn="l" marL="203200" indent="-203200">
               <a:spcAft>
                 <a:spcPts val="800"/>
               </a:spcAft>
@@ -3582,7 +3974,7 @@
               <a:buChar char="▪"/>
             </a:pPr>
             <a:r>
-              <a:rPr lang="en-US" sz="2000" dirty="0">
+              <a:rPr lang="en-US" sz="1700" dirty="0">
                 <a:solidFill>
                   <a:srgbClr val="2C2C2A"/>
                 </a:solidFill>
@@ -3590,9 +3982,9 @@
                 <a:ea typeface="Inter" pitchFamily="34" charset="-122"/>
                 <a:cs typeface="Inter" pitchFamily="34" charset="-120"/>
               </a:rPr>
-              <a:t>Adoption KPIs at role level protect 1.5-2.5 M…</a:t>
-            </a:r>
-            <a:pPr algn="l" marL="228600" indent="-228600">
+              <a:t>Week 3 — validate financials with confidence-banded value view</a:t>
+            </a:r>
+            <a:pPr algn="l" marL="203200" indent="-203200">
               <a:spcAft>
                 <a:spcPts val="800"/>
               </a:spcAft>
@@ -3600,7 +3992,7 @@
               <a:buChar char="▪"/>
             </a:pPr>
             <a:r>
-              <a:rPr lang="en-US" sz="2000" dirty="0">
+              <a:rPr lang="en-US" sz="1700" dirty="0">
                 <a:solidFill>
                   <a:srgbClr val="2C2C2A"/>
                 </a:solidFill>
@@ -3608,9 +4000,9 @@
                 <a:ea typeface="Inter" pitchFamily="34" charset="-122"/>
                 <a:cs typeface="Inter" pitchFamily="34" charset="-120"/>
               </a:rPr>
-              <a:t>US buyers, districts and partners rehearse one message…</a:t>
-            </a:r>
-            <a:pPr algn="l" marL="228600" indent="-228600">
+              <a:t>Week 4 — executive review: scale, adjust or stop</a:t>
+            </a:r>
+            <a:pPr algn="l" marL="203200" indent="-203200">
               <a:spcAft>
                 <a:spcPts val="800"/>
               </a:spcAft>
@@ -3618,7 +4010,7 @@
               <a:buChar char="▪"/>
             </a:pPr>
             <a:r>
-              <a:rPr lang="en-US" sz="2000" dirty="0">
+              <a:rPr lang="en-US" sz="1700" dirty="0">
                 <a:solidFill>
                   <a:srgbClr val="2C2C2A"/>
                 </a:solidFill>
@@ -3626,9 +4018,9 @@
                 <a:ea typeface="Inter" pitchFamily="34" charset="-122"/>
                 <a:cs typeface="Inter" pitchFamily="34" charset="-120"/>
               </a:rPr>
-              <a:t>Removes 1.4-3.3 M EUR/yr of narrative-debt value leakage</a:t>
-            </a:r>
-            <a:endParaRPr lang="en-US" sz="2000" dirty="0"/>
+              <a:t>Require confidence-banded value cases before Gate 2 funding</a:t>
+            </a:r>
+            <a:endParaRPr lang="en-US" sz="1700" dirty="0"/>
           </a:p>
         </p:txBody>
       </p:sp>
@@ -3643,6 +4035,391 @@
 <file path=ppt/slides/slide13.xml><?xml version="1.0" encoding="utf-8"?>
 <p:sld xmlns:a="http://schemas.openxmlformats.org/drawingml/2006/main" xmlns:r="http://schemas.openxmlformats.org/officeDocument/2006/relationships" xmlns:p="http://schemas.openxmlformats.org/presentationml/2006/main">
   <p:cSld name="Slide 13">
+    <p:bg>
+      <p:bgPr>
+        <a:solidFill>
+          <a:srgbClr val="FFFFFF"/>
+        </a:solidFill>
+      </p:bgPr>
+    </p:bg>
+    <p:spTree>
+      <p:nvGrpSpPr>
+        <p:cNvPr id="1" name=""/>
+        <p:cNvGrpSpPr/>
+        <p:nvPr/>
+      </p:nvGrpSpPr>
+      <p:grpSpPr>
+        <a:xfrm>
+          <a:off x="0" y="0"/>
+          <a:ext cx="0" cy="0"/>
+          <a:chOff x="0" y="0"/>
+          <a:chExt cx="0" cy="0"/>
+        </a:xfrm>
+      </p:grpSpPr>
+      <p:sp>
+        <p:nvSpPr>
+          <p:cNvPr id="2" name="Shape 0"/>
+          <p:cNvSpPr/>
+          <p:nvPr/>
+        </p:nvSpPr>
+        <p:spPr>
+          <a:xfrm>
+            <a:off x="0" y="0"/>
+            <a:ext cx="9144000" cy="109728"/>
+          </a:xfrm>
+          <a:prstGeom prst="rect">
+            <a:avLst/>
+          </a:prstGeom>
+          <a:solidFill>
+            <a:srgbClr val="1D9E75"/>
+          </a:solidFill>
+          <a:ln w="12700">
+            <a:solidFill>
+              <a:srgbClr val="1D9E75"/>
+            </a:solidFill>
+            <a:prstDash val="solid"/>
+          </a:ln>
+        </p:spPr>
+      </p:sp>
+      <p:sp>
+        <p:nvSpPr>
+          <p:cNvPr id="3" name="Text 1"/>
+          <p:cNvSpPr/>
+          <p:nvPr/>
+        </p:nvSpPr>
+        <p:spPr>
+          <a:xfrm>
+            <a:off x="548640" y="457200"/>
+            <a:ext cx="8046720" cy="914400"/>
+          </a:xfrm>
+          <a:prstGeom prst="rect">
+            <a:avLst/>
+          </a:prstGeom>
+          <a:noFill/>
+          <a:ln/>
+        </p:spPr>
+        <p:txBody>
+          <a:bodyPr wrap="square" rtlCol="0" anchor="t">
+            <a:normAutofit/>
+          </a:bodyPr>
+          <a:lstStyle/>
+          <a:p>
+            <a:pPr algn="l" indent="0" marL="0">
+              <a:lnSpc>
+                <a:spcPct val="98000"/>
+              </a:lnSpc>
+              <a:buNone/>
+            </a:pPr>
+            <a:r>
+              <a:rPr lang="en-US" sz="3000" b="1" dirty="0">
+                <a:solidFill>
+                  <a:srgbClr val="0C447C"/>
+                </a:solidFill>
+                <a:latin typeface="Merriweather" pitchFamily="34" charset="0"/>
+                <a:ea typeface="Merriweather" pitchFamily="34" charset="-122"/>
+                <a:cs typeface="Merriweather" pitchFamily="34" charset="-120"/>
+              </a:rPr>
+              <a:t>What to expect: one board narrative that converts digital signals into governed value</a:t>
+            </a:r>
+            <a:endParaRPr lang="en-US" sz="3000" dirty="0"/>
+          </a:p>
+        </p:txBody>
+      </p:sp>
+      <p:sp>
+        <p:nvSpPr>
+          <p:cNvPr id="4" name="Shape 2"/>
+          <p:cNvSpPr/>
+          <p:nvPr/>
+        </p:nvSpPr>
+        <p:spPr>
+          <a:xfrm>
+            <a:off x="548640" y="1417320"/>
+            <a:ext cx="8046720" cy="0"/>
+          </a:xfrm>
+          <a:prstGeom prst="line">
+            <a:avLst/>
+          </a:prstGeom>
+          <a:noFill/>
+          <a:ln w="12700">
+            <a:solidFill>
+              <a:srgbClr val="E3E7EE"/>
+            </a:solidFill>
+            <a:prstDash val="solid"/>
+          </a:ln>
+        </p:spPr>
+      </p:sp>
+      <p:sp>
+        <p:nvSpPr>
+          <p:cNvPr id="5" name="Text 3"/>
+          <p:cNvSpPr/>
+          <p:nvPr/>
+        </p:nvSpPr>
+        <p:spPr>
+          <a:xfrm>
+            <a:off x="548640" y="4800600"/>
+            <a:ext cx="5486400" cy="274320"/>
+          </a:xfrm>
+          <a:prstGeom prst="rect">
+            <a:avLst/>
+          </a:prstGeom>
+          <a:noFill/>
+          <a:ln/>
+        </p:spPr>
+        <p:txBody>
+          <a:bodyPr wrap="square" rtlCol="0" anchor="ctr"/>
+          <a:lstStyle/>
+          <a:p>
+            <a:pPr algn="l" indent="0" marL="0">
+              <a:buNone/>
+            </a:pPr>
+            <a:r>
+              <a:rPr lang="en-US" sz="1100" dirty="0">
+                <a:solidFill>
+                  <a:srgbClr val="8A94A6"/>
+                </a:solidFill>
+                <a:latin typeface="Inter" pitchFamily="34" charset="0"/>
+                <a:ea typeface="Inter" pitchFamily="34" charset="-122"/>
+                <a:cs typeface="Inter" pitchFamily="34" charset="-120"/>
+              </a:rPr>
+              <a:t>Atelier Toys</a:t>
+            </a:r>
+            <a:endParaRPr lang="en-US" sz="1100" dirty="0"/>
+          </a:p>
+        </p:txBody>
+      </p:sp>
+      <p:sp>
+        <p:nvSpPr>
+          <p:cNvPr id="6" name="Text 4"/>
+          <p:cNvSpPr/>
+          <p:nvPr/>
+        </p:nvSpPr>
+        <p:spPr>
+          <a:xfrm>
+            <a:off x="8229600" y="4800600"/>
+            <a:ext cx="548640" cy="274320"/>
+          </a:xfrm>
+          <a:prstGeom prst="rect">
+            <a:avLst/>
+          </a:prstGeom>
+          <a:noFill/>
+          <a:ln/>
+        </p:spPr>
+        <p:txBody>
+          <a:bodyPr wrap="square" rtlCol="0" anchor="ctr"/>
+          <a:lstStyle/>
+          <a:p>
+            <a:pPr algn="r" indent="0" marL="0">
+              <a:buNone/>
+            </a:pPr>
+            <a:r>
+              <a:rPr lang="en-US" sz="1100" dirty="0">
+                <a:solidFill>
+                  <a:srgbClr val="8A94A6"/>
+                </a:solidFill>
+                <a:latin typeface="Inter" pitchFamily="34" charset="0"/>
+                <a:ea typeface="Inter" pitchFamily="34" charset="-122"/>
+                <a:cs typeface="Inter" pitchFamily="34" charset="-120"/>
+              </a:rPr>
+              <a:t>12</a:t>
+            </a:r>
+            <a:endParaRPr lang="en-US" sz="1100" dirty="0"/>
+          </a:p>
+        </p:txBody>
+      </p:sp>
+      <p:sp>
+        <p:nvSpPr>
+          <p:cNvPr id="7" name="Shape 5"/>
+          <p:cNvSpPr/>
+          <p:nvPr/>
+        </p:nvSpPr>
+        <p:spPr>
+          <a:xfrm>
+            <a:off x="7545629" y="164592"/>
+            <a:ext cx="1232611" cy="237744"/>
+          </a:xfrm>
+          <a:prstGeom prst="roundRect">
+            <a:avLst>
+              <a:gd name="adj" fmla="val 15385"/>
+            </a:avLst>
+          </a:prstGeom>
+          <a:solidFill>
+            <a:srgbClr val="1D9E75"/>
+          </a:solidFill>
+          <a:ln w="12700">
+            <a:solidFill>
+              <a:srgbClr val="1D9E75"/>
+            </a:solidFill>
+            <a:prstDash val="solid"/>
+          </a:ln>
+        </p:spPr>
+      </p:sp>
+      <p:sp>
+        <p:nvSpPr>
+          <p:cNvPr id="8" name="Text 6"/>
+          <p:cNvSpPr/>
+          <p:nvPr/>
+        </p:nvSpPr>
+        <p:spPr>
+          <a:xfrm>
+            <a:off x="7545629" y="164592"/>
+            <a:ext cx="1232611" cy="237744"/>
+          </a:xfrm>
+          <a:prstGeom prst="rect">
+            <a:avLst/>
+          </a:prstGeom>
+          <a:noFill/>
+          <a:ln/>
+        </p:spPr>
+        <p:txBody>
+          <a:bodyPr wrap="square" rtlCol="0" anchor="ctr"/>
+          <a:lstStyle/>
+          <a:p>
+            <a:pPr algn="ctr" indent="0" marL="0">
+              <a:buNone/>
+            </a:pPr>
+            <a:r>
+              <a:rPr lang="en-US" sz="700" b="1" dirty="0">
+                <a:solidFill>
+                  <a:srgbClr val="FFFFFF"/>
+                </a:solidFill>
+                <a:latin typeface="Inter" pitchFamily="34" charset="0"/>
+                <a:ea typeface="Inter" pitchFamily="34" charset="-122"/>
+                <a:cs typeface="Inter" pitchFamily="34" charset="-120"/>
+              </a:rPr>
+              <a:t>UNIT ECONOMICS</a:t>
+            </a:r>
+            <a:endParaRPr lang="en-US" sz="700" dirty="0"/>
+          </a:p>
+        </p:txBody>
+      </p:sp>
+      <p:sp>
+        <p:nvSpPr>
+          <p:cNvPr id="9" name="Text 7"/>
+          <p:cNvSpPr/>
+          <p:nvPr/>
+        </p:nvSpPr>
+        <p:spPr>
+          <a:xfrm>
+            <a:off x="548640" y="1554480"/>
+            <a:ext cx="8046720" cy="3017520"/>
+          </a:xfrm>
+          <a:prstGeom prst="rect">
+            <a:avLst/>
+          </a:prstGeom>
+          <a:noFill/>
+          <a:ln/>
+        </p:spPr>
+        <p:txBody>
+          <a:bodyPr wrap="square" rtlCol="0" anchor="t">
+            <a:normAutofit/>
+          </a:bodyPr>
+          <a:lstStyle/>
+          <a:p>
+            <a:pPr algn="l" marL="228600" indent="-228600">
+              <a:spcAft>
+                <a:spcPts val="800"/>
+              </a:spcAft>
+              <a:buSzPct val="100000"/>
+              <a:buChar char="▪"/>
+            </a:pPr>
+            <a:r>
+              <a:rPr lang="en-US" sz="2000" dirty="0">
+                <a:solidFill>
+                  <a:srgbClr val="2C2C2A"/>
+                </a:solidFill>
+                <a:latin typeface="Inter" pitchFamily="34" charset="0"/>
+                <a:ea typeface="Inter" pitchFamily="34" charset="-122"/>
+                <a:cs typeface="Inter" pitchFamily="34" charset="-120"/>
+              </a:rPr>
+              <a:t>Every Wave 1 initiative expressible as a sub-thesis…</a:t>
+            </a:r>
+            <a:pPr algn="l" marL="228600" indent="-228600">
+              <a:spcAft>
+                <a:spcPts val="800"/>
+              </a:spcAft>
+              <a:buSzPct val="100000"/>
+              <a:buChar char="▪"/>
+            </a:pPr>
+            <a:r>
+              <a:rPr lang="en-US" sz="2000" dirty="0">
+                <a:solidFill>
+                  <a:srgbClr val="2C2C2A"/>
+                </a:solidFill>
+                <a:latin typeface="Inter" pitchFamily="34" charset="0"/>
+                <a:ea typeface="Inter" pitchFamily="34" charset="-122"/>
+                <a:cs typeface="Inter" pitchFamily="34" charset="-120"/>
+              </a:rPr>
+              <a:t>Decision ledger ends reopened decisions and lost momentum</a:t>
+            </a:r>
+            <a:pPr algn="l" marL="228600" indent="-228600">
+              <a:spcAft>
+                <a:spcPts val="800"/>
+              </a:spcAft>
+              <a:buSzPct val="100000"/>
+              <a:buChar char="▪"/>
+            </a:pPr>
+            <a:r>
+              <a:rPr lang="en-US" sz="2000" dirty="0">
+                <a:solidFill>
+                  <a:srgbClr val="2C2C2A"/>
+                </a:solidFill>
+                <a:latin typeface="Inter" pitchFamily="34" charset="0"/>
+                <a:ea typeface="Inter" pitchFamily="34" charset="-122"/>
+                <a:cs typeface="Inter" pitchFamily="34" charset="-120"/>
+              </a:rPr>
+              <a:t>Adoption KPIs at role level protect 1.5-2.5 M…</a:t>
+            </a:r>
+            <a:pPr algn="l" marL="228600" indent="-228600">
+              <a:spcAft>
+                <a:spcPts val="800"/>
+              </a:spcAft>
+              <a:buSzPct val="100000"/>
+              <a:buChar char="▪"/>
+            </a:pPr>
+            <a:r>
+              <a:rPr lang="en-US" sz="2000" dirty="0">
+                <a:solidFill>
+                  <a:srgbClr val="2C2C2A"/>
+                </a:solidFill>
+                <a:latin typeface="Inter" pitchFamily="34" charset="0"/>
+                <a:ea typeface="Inter" pitchFamily="34" charset="-122"/>
+                <a:cs typeface="Inter" pitchFamily="34" charset="-120"/>
+              </a:rPr>
+              <a:t>US buyers, districts and partners rehearse one message…</a:t>
+            </a:r>
+            <a:pPr algn="l" marL="228600" indent="-228600">
+              <a:spcAft>
+                <a:spcPts val="800"/>
+              </a:spcAft>
+              <a:buSzPct val="100000"/>
+              <a:buChar char="▪"/>
+            </a:pPr>
+            <a:r>
+              <a:rPr lang="en-US" sz="2000" dirty="0">
+                <a:solidFill>
+                  <a:srgbClr val="2C2C2A"/>
+                </a:solidFill>
+                <a:latin typeface="Inter" pitchFamily="34" charset="0"/>
+                <a:ea typeface="Inter" pitchFamily="34" charset="-122"/>
+                <a:cs typeface="Inter" pitchFamily="34" charset="-120"/>
+              </a:rPr>
+              <a:t>Removes 1.4-3.3 M EUR/yr of narrative-debt value leakage</a:t>
+            </a:r>
+            <a:endParaRPr lang="en-US" sz="2000" dirty="0"/>
+          </a:p>
+        </p:txBody>
+      </p:sp>
+    </p:spTree>
+  </p:cSld>
+  <p:clrMapOvr>
+    <a:masterClrMapping/>
+  </p:clrMapOvr>
+</p:sld>
+</file>
+
+<file path=ppt/slides/slide14.xml><?xml version="1.0" encoding="utf-8"?>
+<p:sld xmlns:a="http://schemas.openxmlformats.org/drawingml/2006/main" xmlns:r="http://schemas.openxmlformats.org/officeDocument/2006/relationships" xmlns:p="http://schemas.openxmlformats.org/presentationml/2006/main">
+  <p:cSld name="Slide 14">
     <p:bg>
       <p:bgPr>
         <a:solidFill>
@@ -4572,14 +5349,81 @@
       </p:sp>
       <p:sp>
         <p:nvSpPr>
-          <p:cNvPr id="9" name="Text 7"/>
-          <p:cNvSpPr/>
-          <p:nvPr/>
-        </p:nvSpPr>
-        <p:spPr>
-          <a:xfrm>
-            <a:off x="548640" y="1554480"/>
-            <a:ext cx="8046720" cy="3017520"/>
+          <p:cNvPr id="9" name="Shape 7"/>
+          <p:cNvSpPr/>
+          <p:nvPr/>
+        </p:nvSpPr>
+        <p:spPr>
+          <a:xfrm>
+            <a:off x="548640" y="1600200"/>
+            <a:ext cx="73152" cy="822960"/>
+          </a:xfrm>
+          <a:prstGeom prst="rect">
+            <a:avLst/>
+          </a:prstGeom>
+          <a:solidFill>
+            <a:srgbClr val="1D9E75"/>
+          </a:solidFill>
+          <a:ln w="12700">
+            <a:solidFill>
+              <a:srgbClr val="1D9E75"/>
+            </a:solidFill>
+            <a:prstDash val="solid"/>
+          </a:ln>
+        </p:spPr>
+      </p:sp>
+      <p:sp>
+        <p:nvSpPr>
+          <p:cNvPr id="10" name="Text 8"/>
+          <p:cNvSpPr/>
+          <p:nvPr/>
+        </p:nvSpPr>
+        <p:spPr>
+          <a:xfrm>
+            <a:off x="749808" y="1554480"/>
+            <a:ext cx="3977640" cy="3063240"/>
+          </a:xfrm>
+          <a:prstGeom prst="rect">
+            <a:avLst/>
+          </a:prstGeom>
+          <a:noFill/>
+          <a:ln/>
+        </p:spPr>
+        <p:txBody>
+          <a:bodyPr wrap="square" rtlCol="0" anchor="t"/>
+          <a:lstStyle/>
+          <a:p>
+            <a:pPr algn="l" indent="0" marL="0">
+              <a:lnSpc>
+                <a:spcPct val="102000"/>
+              </a:lnSpc>
+              <a:buNone/>
+            </a:pPr>
+            <a:r>
+              <a:rPr lang="en-US" sz="2300" b="1" dirty="0">
+                <a:solidFill>
+                  <a:srgbClr val="0C447C"/>
+                </a:solidFill>
+                <a:latin typeface="Merriweather" pitchFamily="34" charset="0"/>
+                <a:ea typeface="Merriweather" pitchFamily="34" charset="-122"/>
+                <a:cs typeface="Merriweather" pitchFamily="34" charset="-120"/>
+              </a:rPr>
+              <a:t>Plant, finance, product, customer success and partners describe one shared gap from different angles: enough data to act earlier, not enough governance discipline to turn data into consistent decisions.</a:t>
+            </a:r>
+            <a:endParaRPr lang="en-US" sz="2300" dirty="0"/>
+          </a:p>
+        </p:txBody>
+      </p:sp>
+      <p:sp>
+        <p:nvSpPr>
+          <p:cNvPr id="11" name="Text 9"/>
+          <p:cNvSpPr/>
+          <p:nvPr/>
+        </p:nvSpPr>
+        <p:spPr>
+          <a:xfrm>
+            <a:off x="5212080" y="1554480"/>
+            <a:ext cx="3383280" cy="3063240"/>
           </a:xfrm>
           <a:prstGeom prst="rect">
             <a:avLst/>
@@ -4593,7 +5437,7 @@
           </a:bodyPr>
           <a:lstStyle/>
           <a:p>
-            <a:pPr algn="l" marL="228600" indent="-228600">
+            <a:pPr algn="l" marL="203200" indent="-203200">
               <a:spcAft>
                 <a:spcPts val="800"/>
               </a:spcAft>
@@ -4601,7 +5445,7 @@
               <a:buChar char="▪"/>
             </a:pPr>
             <a:r>
-              <a:rPr lang="en-US" sz="2000" dirty="0">
+              <a:rPr lang="en-US" sz="1700" dirty="0">
                 <a:solidFill>
                   <a:srgbClr val="2C2C2A"/>
                 </a:solidFill>
@@ -4611,7 +5455,7 @@
               </a:rPr>
               <a:t>Signals arrive late — value leaks before intervention</a:t>
             </a:r>
-            <a:pPr algn="l" marL="228600" indent="-228600">
+            <a:pPr algn="l" marL="203200" indent="-203200">
               <a:spcAft>
                 <a:spcPts val="800"/>
               </a:spcAft>
@@ -4619,7 +5463,7 @@
               <a:buChar char="▪"/>
             </a:pPr>
             <a:r>
-              <a:rPr lang="en-US" sz="2000" dirty="0">
+              <a:rPr lang="en-US" sz="1700" dirty="0">
                 <a:solidFill>
                   <a:srgbClr val="2C2C2A"/>
                 </a:solidFill>
@@ -4627,9 +5471,9 @@
                 <a:ea typeface="Inter" pitchFamily="34" charset="-122"/>
                 <a:cs typeface="Inter" pitchFamily="34" charset="-120"/>
               </a:rPr>
-              <a:t>Data definitions vary — portfolio progress is not…</a:t>
-            </a:r>
-            <a:pPr algn="l" marL="228600" indent="-228600">
+              <a:t>Data definitions vary — portfolio progress is not comparable</a:t>
+            </a:r>
+            <a:pPr algn="l" marL="203200" indent="-203200">
               <a:spcAft>
                 <a:spcPts val="800"/>
               </a:spcAft>
@@ -4637,7 +5481,7 @@
               <a:buChar char="▪"/>
             </a:pPr>
             <a:r>
-              <a:rPr lang="en-US" sz="2000" dirty="0">
+              <a:rPr lang="en-US" sz="1700" dirty="0">
                 <a:solidFill>
                   <a:srgbClr val="2C2C2A"/>
                 </a:solidFill>
@@ -4645,9 +5489,9 @@
                 <a:ea typeface="Inter" pitchFamily="34" charset="-122"/>
                 <a:cs typeface="Inter" pitchFamily="34" charset="-120"/>
               </a:rPr>
-              <a:t>Pilots lack scale gates — real gains stay…</a:t>
-            </a:r>
-            <a:pPr algn="l" marL="228600" indent="-228600">
+              <a:t>Pilots lack scale gates — real gains stay unrepeatable</a:t>
+            </a:r>
+            <a:pPr algn="l" marL="203200" indent="-203200">
               <a:spcAft>
                 <a:spcPts val="800"/>
               </a:spcAft>
@@ -4655,7 +5499,7 @@
               <a:buChar char="▪"/>
             </a:pPr>
             <a:r>
-              <a:rPr lang="en-US" sz="2000" dirty="0">
+              <a:rPr lang="en-US" sz="1700" dirty="0">
                 <a:solidFill>
                   <a:srgbClr val="2C2C2A"/>
                 </a:solidFill>
@@ -4665,7 +5509,7 @@
               </a:rPr>
               <a:t>Owners named, cross-function dependencies weak</a:t>
             </a:r>
-            <a:pPr algn="l" marL="228600" indent="-228600">
+            <a:pPr algn="l" marL="203200" indent="-203200">
               <a:spcAft>
                 <a:spcPts val="800"/>
               </a:spcAft>
@@ -4673,7 +5517,7 @@
               <a:buChar char="▪"/>
             </a:pPr>
             <a:r>
-              <a:rPr lang="en-US" sz="2000" dirty="0">
+              <a:rPr lang="en-US" sz="1700" dirty="0">
                 <a:solidFill>
                   <a:srgbClr val="2C2C2A"/>
                 </a:solidFill>
@@ -4683,7 +5527,7 @@
               </a:rPr>
               <a:t>Governance is active but not yet evidence-driven</a:t>
             </a:r>
-            <a:endParaRPr lang="en-US" sz="2000" dirty="0"/>
+            <a:endParaRPr lang="en-US" sz="1700" dirty="0"/>
           </a:p>
         </p:txBody>
       </p:sp>
@@ -5105,7 +5949,7 @@
                 <a:ea typeface="Merriweather" pitchFamily="34" charset="-122"/>
                 <a:cs typeface="Merriweather" pitchFamily="34" charset="-120"/>
               </a:rPr>
-              <a:t>The executive heatmap sequences Wave 1 where evidence and value both concentrate</a:t>
+              <a:t>The evidence base is decision-grade, and the value pool is concentrated</a:t>
             </a:r>
             <a:endParaRPr lang="en-US" sz="3000" dirty="0"/>
           </a:p>
@@ -5272,7 +6116,7 @@
                 <a:ea typeface="Inter" pitchFamily="34" charset="-122"/>
                 <a:cs typeface="Inter" pitchFamily="34" charset="-120"/>
               </a:rPr>
-              <a:t>RISK</a:t>
+              <a:t>KPIs</a:t>
             </a:r>
             <a:endParaRPr lang="en-US" sz="700" dirty="0"/>
           </a:p>
@@ -5286,18 +6130,18 @@
         </p:nvSpPr>
         <p:spPr>
           <a:xfrm>
-            <a:off x="548640" y="1920240"/>
-            <a:ext cx="310896" cy="310896"/>
-          </a:xfrm>
-          <a:prstGeom prst="ellipse">
+            <a:off x="548640" y="1554480"/>
+            <a:ext cx="1840230" cy="2148840"/>
+          </a:xfrm>
+          <a:prstGeom prst="rect">
             <a:avLst/>
           </a:prstGeom>
           <a:solidFill>
-            <a:srgbClr val="FFFFFF"/>
+            <a:srgbClr val="F5F8FC"/>
           </a:solidFill>
           <a:ln w="12700">
             <a:solidFill>
-              <a:srgbClr val="1D9E75"/>
+              <a:srgbClr val="E3E7EE"/>
             </a:solidFill>
             <a:prstDash val="solid"/>
           </a:ln>
@@ -5311,14 +6155,11 @@
         </p:nvSpPr>
         <p:spPr>
           <a:xfrm>
-            <a:off x="548640" y="1920240"/>
-            <a:ext cx="310896" cy="310896"/>
-          </a:xfrm>
-          <a:prstGeom prst="pie">
-            <a:avLst>
-              <a:gd name="adj1" fmla="val 0"/>
-              <a:gd name="adj2" fmla="val 21600000"/>
-            </a:avLst>
+            <a:off x="548640" y="1554480"/>
+            <a:ext cx="1840230" cy="64008"/>
+          </a:xfrm>
+          <a:prstGeom prst="rect">
+            <a:avLst/>
           </a:prstGeom>
           <a:solidFill>
             <a:srgbClr val="1D9E75"/>
@@ -5339,24 +6180,68 @@
         </p:nvSpPr>
         <p:spPr>
           <a:xfrm>
-            <a:off x="960120" y="1920240"/>
-            <a:ext cx="5943600" cy="365760"/>
-          </a:xfrm>
-          <a:prstGeom prst="rect">
-            <a:avLst/>
-          </a:prstGeom>
-          <a:noFill/>
-          <a:ln/>
-        </p:spPr>
-        <p:txBody>
-          <a:bodyPr wrap="square" rtlCol="0" anchor="ctr"/>
+            <a:off x="658368" y="1810512"/>
+            <a:ext cx="1620774" cy="868680"/>
+          </a:xfrm>
+          <a:prstGeom prst="rect">
+            <a:avLst/>
+          </a:prstGeom>
+          <a:noFill/>
+          <a:ln/>
+        </p:spPr>
+        <p:txBody>
+          <a:bodyPr wrap="square" rtlCol="0" anchor="t">
+            <a:normAutofit/>
+          </a:bodyPr>
           <a:lstStyle/>
           <a:p>
             <a:pPr algn="l" indent="0" marL="0">
               <a:buNone/>
             </a:pPr>
             <a:r>
-              <a:rPr lang="en-US" sz="1100" dirty="0">
+              <a:rPr lang="en-US" sz="3000" b="1" dirty="0">
+                <a:solidFill>
+                  <a:srgbClr val="0C447C"/>
+                </a:solidFill>
+                <a:latin typeface="Merriweather" pitchFamily="34" charset="0"/>
+                <a:ea typeface="Merriweather" pitchFamily="34" charset="-122"/>
+                <a:cs typeface="Merriweather" pitchFamily="34" charset="-120"/>
+              </a:rPr>
+              <a:t>440</a:t>
+            </a:r>
+            <a:endParaRPr lang="en-US" sz="3000" dirty="0"/>
+          </a:p>
+        </p:txBody>
+      </p:sp>
+      <p:sp>
+        <p:nvSpPr>
+          <p:cNvPr id="12" name="Text 10"/>
+          <p:cNvSpPr/>
+          <p:nvPr/>
+        </p:nvSpPr>
+        <p:spPr>
+          <a:xfrm>
+            <a:off x="658368" y="2724912"/>
+            <a:ext cx="1620774" cy="640080"/>
+          </a:xfrm>
+          <a:prstGeom prst="rect">
+            <a:avLst/>
+          </a:prstGeom>
+          <a:noFill/>
+          <a:ln/>
+        </p:spPr>
+        <p:txBody>
+          <a:bodyPr wrap="square" rtlCol="0" anchor="t"/>
+          <a:lstStyle/>
+          <a:p>
+            <a:pPr algn="l" indent="0" marL="0">
+              <a:lnSpc>
+                <a:spcPct val="100000"/>
+              </a:lnSpc>
+              <a:buNone/>
+            </a:pPr>
+            <a:r>
+              <a:rPr lang="en-US" sz="1200" b="1" dirty="0">
                 <a:solidFill>
                   <a:srgbClr val="2C2C2A"/>
                 </a:solidFill>
@@ -5364,71 +6249,71 @@
                 <a:ea typeface="Inter" pitchFamily="34" charset="-122"/>
                 <a:cs typeface="Inter" pitchFamily="34" charset="-120"/>
               </a:rPr>
-              <a:t>Factory telemetry &amp; Digital Twin</a:t>
-            </a:r>
-            <a:endParaRPr lang="en-US" sz="1100" dirty="0"/>
-          </a:p>
-        </p:txBody>
-      </p:sp>
-      <p:sp>
-        <p:nvSpPr>
-          <p:cNvPr id="12" name="Text 10"/>
-          <p:cNvSpPr/>
-          <p:nvPr/>
-        </p:nvSpPr>
-        <p:spPr>
-          <a:xfrm>
-            <a:off x="6949440" y="1920240"/>
-            <a:ext cx="1645920" cy="365760"/>
-          </a:xfrm>
-          <a:prstGeom prst="rect">
-            <a:avLst/>
-          </a:prstGeom>
-          <a:noFill/>
-          <a:ln/>
-        </p:spPr>
-        <p:txBody>
-          <a:bodyPr wrap="square" rtlCol="0" anchor="ctr"/>
-          <a:lstStyle/>
-          <a:p>
-            <a:pPr algn="r" indent="0" marL="0">
+              <a:t>Interview answers analysed</a:t>
+            </a:r>
+            <a:endParaRPr lang="en-US" sz="1200" dirty="0"/>
+          </a:p>
+        </p:txBody>
+      </p:sp>
+      <p:sp>
+        <p:nvSpPr>
+          <p:cNvPr id="13" name="Text 11"/>
+          <p:cNvSpPr/>
+          <p:nvPr/>
+        </p:nvSpPr>
+        <p:spPr>
+          <a:xfrm>
+            <a:off x="658368" y="3246120"/>
+            <a:ext cx="1620774" cy="384048"/>
+          </a:xfrm>
+          <a:prstGeom prst="rect">
+            <a:avLst/>
+          </a:prstGeom>
+          <a:noFill/>
+          <a:ln/>
+        </p:spPr>
+        <p:txBody>
+          <a:bodyPr wrap="square" rtlCol="0" anchor="b"/>
+          <a:lstStyle/>
+          <a:p>
+            <a:pPr algn="l" indent="0" marL="0">
               <a:buNone/>
             </a:pPr>
             <a:r>
-              <a:rPr lang="en-US" sz="900" i="1" dirty="0">
-                <a:solidFill>
-                  <a:srgbClr val="2C2C2A"/>
-                </a:solidFill>
-                <a:latin typeface="Inter" pitchFamily="34" charset="0"/>
-                <a:ea typeface="Inter" pitchFamily="34" charset="-122"/>
-                <a:cs typeface="Inter" pitchFamily="34" charset="-120"/>
-              </a:rPr>
-              <a:t>pełny</a:t>
-            </a:r>
-            <a:endParaRPr lang="en-US" sz="900" dirty="0"/>
-          </a:p>
-        </p:txBody>
-      </p:sp>
-      <p:sp>
-        <p:nvSpPr>
-          <p:cNvPr id="13" name="Shape 11"/>
-          <p:cNvSpPr/>
-          <p:nvPr/>
-        </p:nvSpPr>
-        <p:spPr>
-          <a:xfrm>
-            <a:off x="548640" y="2331720"/>
-            <a:ext cx="310896" cy="310896"/>
-          </a:xfrm>
-          <a:prstGeom prst="ellipse">
+              <a:rPr lang="en-US" sz="1000" i="1" dirty="0">
+                <a:solidFill>
+                  <a:srgbClr val="8A94A6"/>
+                </a:solidFill>
+                <a:latin typeface="Inter" pitchFamily="34" charset="0"/>
+                <a:ea typeface="Inter" pitchFamily="34" charset="-122"/>
+                <a:cs typeface="Inter" pitchFamily="34" charset="-120"/>
+              </a:rPr>
+              <a:t>22 leadership personas</a:t>
+            </a:r>
+            <a:endParaRPr lang="en-US" sz="1000" dirty="0"/>
+          </a:p>
+        </p:txBody>
+      </p:sp>
+      <p:sp>
+        <p:nvSpPr>
+          <p:cNvPr id="14" name="Shape 12"/>
+          <p:cNvSpPr/>
+          <p:nvPr/>
+        </p:nvSpPr>
+        <p:spPr>
+          <a:xfrm>
+            <a:off x="2617470" y="1554480"/>
+            <a:ext cx="1840230" cy="2148840"/>
+          </a:xfrm>
+          <a:prstGeom prst="rect">
             <a:avLst/>
           </a:prstGeom>
           <a:solidFill>
-            <a:srgbClr val="FFFFFF"/>
+            <a:srgbClr val="F5F8FC"/>
           </a:solidFill>
           <a:ln w="12700">
             <a:solidFill>
-              <a:srgbClr val="1D9E75"/>
+              <a:srgbClr val="E3E7EE"/>
             </a:solidFill>
             <a:prstDash val="solid"/>
           </a:ln>
@@ -5436,20 +6321,17 @@
       </p:sp>
       <p:sp>
         <p:nvSpPr>
-          <p:cNvPr id="14" name="Shape 12"/>
-          <p:cNvSpPr/>
-          <p:nvPr/>
-        </p:nvSpPr>
-        <p:spPr>
-          <a:xfrm>
-            <a:off x="548640" y="2331720"/>
-            <a:ext cx="310896" cy="310896"/>
-          </a:xfrm>
-          <a:prstGeom prst="pie">
-            <a:avLst>
-              <a:gd name="adj1" fmla="val 0"/>
-              <a:gd name="adj2" fmla="val 21600000"/>
-            </a:avLst>
+          <p:cNvPr id="15" name="Shape 13"/>
+          <p:cNvSpPr/>
+          <p:nvPr/>
+        </p:nvSpPr>
+        <p:spPr>
+          <a:xfrm>
+            <a:off x="2617470" y="1554480"/>
+            <a:ext cx="1840230" cy="64008"/>
+          </a:xfrm>
+          <a:prstGeom prst="rect">
+            <a:avLst/>
           </a:prstGeom>
           <a:solidFill>
             <a:srgbClr val="1D9E75"/>
@@ -5464,30 +6346,74 @@
       </p:sp>
       <p:sp>
         <p:nvSpPr>
-          <p:cNvPr id="15" name="Text 13"/>
-          <p:cNvSpPr/>
-          <p:nvPr/>
-        </p:nvSpPr>
-        <p:spPr>
-          <a:xfrm>
-            <a:off x="960120" y="2331720"/>
-            <a:ext cx="5943600" cy="365760"/>
-          </a:xfrm>
-          <a:prstGeom prst="rect">
-            <a:avLst/>
-          </a:prstGeom>
-          <a:noFill/>
-          <a:ln/>
-        </p:spPr>
-        <p:txBody>
-          <a:bodyPr wrap="square" rtlCol="0" anchor="ctr"/>
+          <p:cNvPr id="16" name="Text 14"/>
+          <p:cNvSpPr/>
+          <p:nvPr/>
+        </p:nvSpPr>
+        <p:spPr>
+          <a:xfrm>
+            <a:off x="2727198" y="1810512"/>
+            <a:ext cx="1620774" cy="868680"/>
+          </a:xfrm>
+          <a:prstGeom prst="rect">
+            <a:avLst/>
+          </a:prstGeom>
+          <a:noFill/>
+          <a:ln/>
+        </p:spPr>
+        <p:txBody>
+          <a:bodyPr wrap="square" rtlCol="0" anchor="t">
+            <a:normAutofit/>
+          </a:bodyPr>
           <a:lstStyle/>
           <a:p>
             <a:pPr algn="l" indent="0" marL="0">
               <a:buNone/>
             </a:pPr>
             <a:r>
-              <a:rPr lang="en-US" sz="1100" dirty="0">
+              <a:rPr lang="en-US" sz="3000" b="1" dirty="0">
+                <a:solidFill>
+                  <a:srgbClr val="0C447C"/>
+                </a:solidFill>
+                <a:latin typeface="Merriweather" pitchFamily="34" charset="0"/>
+                <a:ea typeface="Merriweather" pitchFamily="34" charset="-122"/>
+                <a:cs typeface="Merriweather" pitchFamily="34" charset="-120"/>
+              </a:rPr>
+              <a:t>14–22 M€</a:t>
+            </a:r>
+            <a:endParaRPr lang="en-US" sz="3000" dirty="0"/>
+          </a:p>
+        </p:txBody>
+      </p:sp>
+      <p:sp>
+        <p:nvSpPr>
+          <p:cNvPr id="17" name="Text 15"/>
+          <p:cNvSpPr/>
+          <p:nvPr/>
+        </p:nvSpPr>
+        <p:spPr>
+          <a:xfrm>
+            <a:off x="2727198" y="2724912"/>
+            <a:ext cx="1620774" cy="640080"/>
+          </a:xfrm>
+          <a:prstGeom prst="rect">
+            <a:avLst/>
+          </a:prstGeom>
+          <a:noFill/>
+          <a:ln/>
+        </p:spPr>
+        <p:txBody>
+          <a:bodyPr wrap="square" rtlCol="0" anchor="t"/>
+          <a:lstStyle/>
+          <a:p>
+            <a:pPr algn="l" indent="0" marL="0">
+              <a:lnSpc>
+                <a:spcPct val="100000"/>
+              </a:lnSpc>
+              <a:buNone/>
+            </a:pPr>
+            <a:r>
+              <a:rPr lang="en-US" sz="1200" b="1" dirty="0">
                 <a:solidFill>
                   <a:srgbClr val="2C2C2A"/>
                 </a:solidFill>
@@ -5495,71 +6421,71 @@
                 <a:ea typeface="Inter" pitchFamily="34" charset="-122"/>
                 <a:cs typeface="Inter" pitchFamily="34" charset="-120"/>
               </a:rPr>
-              <a:t>Supplier control tower</a:t>
-            </a:r>
-            <a:endParaRPr lang="en-US" sz="1100" dirty="0"/>
-          </a:p>
-        </p:txBody>
-      </p:sp>
-      <p:sp>
-        <p:nvSpPr>
-          <p:cNvPr id="16" name="Text 14"/>
-          <p:cNvSpPr/>
-          <p:nvPr/>
-        </p:nvSpPr>
-        <p:spPr>
-          <a:xfrm>
-            <a:off x="6949440" y="2331720"/>
-            <a:ext cx="1645920" cy="365760"/>
-          </a:xfrm>
-          <a:prstGeom prst="rect">
-            <a:avLst/>
-          </a:prstGeom>
-          <a:noFill/>
-          <a:ln/>
-        </p:spPr>
-        <p:txBody>
-          <a:bodyPr wrap="square" rtlCol="0" anchor="ctr"/>
-          <a:lstStyle/>
-          <a:p>
-            <a:pPr algn="r" indent="0" marL="0">
+              <a:t>Run-rate value at stake</a:t>
+            </a:r>
+            <a:endParaRPr lang="en-US" sz="1200" dirty="0"/>
+          </a:p>
+        </p:txBody>
+      </p:sp>
+      <p:sp>
+        <p:nvSpPr>
+          <p:cNvPr id="18" name="Text 16"/>
+          <p:cNvSpPr/>
+          <p:nvPr/>
+        </p:nvSpPr>
+        <p:spPr>
+          <a:xfrm>
+            <a:off x="2727198" y="3246120"/>
+            <a:ext cx="1620774" cy="384048"/>
+          </a:xfrm>
+          <a:prstGeom prst="rect">
+            <a:avLst/>
+          </a:prstGeom>
+          <a:noFill/>
+          <a:ln/>
+        </p:spPr>
+        <p:txBody>
+          <a:bodyPr wrap="square" rtlCol="0" anchor="b"/>
+          <a:lstStyle/>
+          <a:p>
+            <a:pPr algn="l" indent="0" marL="0">
               <a:buNone/>
             </a:pPr>
             <a:r>
-              <a:rPr lang="en-US" sz="900" i="1" dirty="0">
-                <a:solidFill>
-                  <a:srgbClr val="2C2C2A"/>
-                </a:solidFill>
-                <a:latin typeface="Inter" pitchFamily="34" charset="0"/>
-                <a:ea typeface="Inter" pitchFamily="34" charset="-122"/>
-                <a:cs typeface="Inter" pitchFamily="34" charset="-120"/>
-              </a:rPr>
-              <a:t>pełny</a:t>
-            </a:r>
-            <a:endParaRPr lang="en-US" sz="900" dirty="0"/>
-          </a:p>
-        </p:txBody>
-      </p:sp>
-      <p:sp>
-        <p:nvSpPr>
-          <p:cNvPr id="17" name="Shape 15"/>
-          <p:cNvSpPr/>
-          <p:nvPr/>
-        </p:nvSpPr>
-        <p:spPr>
-          <a:xfrm>
-            <a:off x="548640" y="2743200"/>
-            <a:ext cx="310896" cy="310896"/>
-          </a:xfrm>
-          <a:prstGeom prst="ellipse">
+              <a:rPr lang="en-US" sz="1000" i="1" dirty="0">
+                <a:solidFill>
+                  <a:srgbClr val="8A94A6"/>
+                </a:solidFill>
+                <a:latin typeface="Inter" pitchFamily="34" charset="0"/>
+                <a:ea typeface="Inter" pitchFamily="34" charset="-122"/>
+                <a:cs typeface="Inter" pitchFamily="34" charset="-120"/>
+              </a:rPr>
+              <a:t>across 6 benchmarked gaps</a:t>
+            </a:r>
+            <a:endParaRPr lang="en-US" sz="1000" dirty="0"/>
+          </a:p>
+        </p:txBody>
+      </p:sp>
+      <p:sp>
+        <p:nvSpPr>
+          <p:cNvPr id="19" name="Shape 17"/>
+          <p:cNvSpPr/>
+          <p:nvPr/>
+        </p:nvSpPr>
+        <p:spPr>
+          <a:xfrm>
+            <a:off x="4686300" y="1554480"/>
+            <a:ext cx="1840230" cy="2148840"/>
+          </a:xfrm>
+          <a:prstGeom prst="rect">
             <a:avLst/>
           </a:prstGeom>
           <a:solidFill>
-            <a:srgbClr val="FFFFFF"/>
+            <a:srgbClr val="F5F8FC"/>
           </a:solidFill>
           <a:ln w="12700">
             <a:solidFill>
-              <a:srgbClr val="1D9E75"/>
+              <a:srgbClr val="E3E7EE"/>
             </a:solidFill>
             <a:prstDash val="solid"/>
           </a:ln>
@@ -5567,20 +6493,17 @@
       </p:sp>
       <p:sp>
         <p:nvSpPr>
-          <p:cNvPr id="18" name="Shape 16"/>
-          <p:cNvSpPr/>
-          <p:nvPr/>
-        </p:nvSpPr>
-        <p:spPr>
-          <a:xfrm>
-            <a:off x="548640" y="2743200"/>
-            <a:ext cx="310896" cy="310896"/>
-          </a:xfrm>
-          <a:prstGeom prst="pie">
-            <a:avLst>
-              <a:gd name="adj1" fmla="val 0"/>
-              <a:gd name="adj2" fmla="val 21600000"/>
-            </a:avLst>
+          <p:cNvPr id="20" name="Shape 18"/>
+          <p:cNvSpPr/>
+          <p:nvPr/>
+        </p:nvSpPr>
+        <p:spPr>
+          <a:xfrm>
+            <a:off x="4686300" y="1554480"/>
+            <a:ext cx="1840230" cy="64008"/>
+          </a:xfrm>
+          <a:prstGeom prst="rect">
+            <a:avLst/>
           </a:prstGeom>
           <a:solidFill>
             <a:srgbClr val="1D9E75"/>
@@ -5595,30 +6518,74 @@
       </p:sp>
       <p:sp>
         <p:nvSpPr>
-          <p:cNvPr id="19" name="Text 17"/>
-          <p:cNvSpPr/>
-          <p:nvPr/>
-        </p:nvSpPr>
-        <p:spPr>
-          <a:xfrm>
-            <a:off x="960120" y="2743200"/>
-            <a:ext cx="5943600" cy="365760"/>
-          </a:xfrm>
-          <a:prstGeom prst="rect">
-            <a:avLst/>
-          </a:prstGeom>
-          <a:noFill/>
-          <a:ln/>
-        </p:spPr>
-        <p:txBody>
-          <a:bodyPr wrap="square" rtlCol="0" anchor="ctr"/>
+          <p:cNvPr id="21" name="Text 19"/>
+          <p:cNvSpPr/>
+          <p:nvPr/>
+        </p:nvSpPr>
+        <p:spPr>
+          <a:xfrm>
+            <a:off x="4796028" y="1810512"/>
+            <a:ext cx="1620774" cy="868680"/>
+          </a:xfrm>
+          <a:prstGeom prst="rect">
+            <a:avLst/>
+          </a:prstGeom>
+          <a:noFill/>
+          <a:ln/>
+        </p:spPr>
+        <p:txBody>
+          <a:bodyPr wrap="square" rtlCol="0" anchor="t">
+            <a:normAutofit/>
+          </a:bodyPr>
           <a:lstStyle/>
           <a:p>
             <a:pPr algn="l" indent="0" marL="0">
               <a:buNone/>
             </a:pPr>
             <a:r>
-              <a:rPr lang="en-US" sz="1100" dirty="0">
+              <a:rPr lang="en-US" sz="3000" b="1" dirty="0">
+                <a:solidFill>
+                  <a:srgbClr val="0C447C"/>
+                </a:solidFill>
+                <a:latin typeface="Merriweather" pitchFamily="34" charset="0"/>
+                <a:ea typeface="Merriweather" pitchFamily="34" charset="-122"/>
+                <a:cs typeface="Merriweather" pitchFamily="34" charset="-120"/>
+              </a:rPr>
+              <a:t>18</a:t>
+            </a:r>
+            <a:endParaRPr lang="en-US" sz="3000" dirty="0"/>
+          </a:p>
+        </p:txBody>
+      </p:sp>
+      <p:sp>
+        <p:nvSpPr>
+          <p:cNvPr id="22" name="Text 20"/>
+          <p:cNvSpPr/>
+          <p:nvPr/>
+        </p:nvSpPr>
+        <p:spPr>
+          <a:xfrm>
+            <a:off x="4796028" y="2724912"/>
+            <a:ext cx="1620774" cy="640080"/>
+          </a:xfrm>
+          <a:prstGeom prst="rect">
+            <a:avLst/>
+          </a:prstGeom>
+          <a:noFill/>
+          <a:ln/>
+        </p:spPr>
+        <p:txBody>
+          <a:bodyPr wrap="square" rtlCol="0" anchor="t"/>
+          <a:lstStyle/>
+          <a:p>
+            <a:pPr algn="l" indent="0" marL="0">
+              <a:lnSpc>
+                <a:spcPct val="100000"/>
+              </a:lnSpc>
+              <a:buNone/>
+            </a:pPr>
+            <a:r>
+              <a:rPr lang="en-US" sz="1200" b="1" dirty="0">
                 <a:solidFill>
                   <a:srgbClr val="2C2C2A"/>
                 </a:solidFill>
@@ -5626,71 +6593,71 @@
                 <a:ea typeface="Inter" pitchFamily="34" charset="-122"/>
                 <a:cs typeface="Inter" pitchFamily="34" charset="-120"/>
               </a:rPr>
-              <a:t>Digital subscription renewal risk</a:t>
-            </a:r>
-            <a:endParaRPr lang="en-US" sz="1100" dirty="0"/>
-          </a:p>
-        </p:txBody>
-      </p:sp>
-      <p:sp>
-        <p:nvSpPr>
-          <p:cNvPr id="20" name="Text 18"/>
-          <p:cNvSpPr/>
-          <p:nvPr/>
-        </p:nvSpPr>
-        <p:spPr>
-          <a:xfrm>
-            <a:off x="6949440" y="2743200"/>
-            <a:ext cx="1645920" cy="365760"/>
-          </a:xfrm>
-          <a:prstGeom prst="rect">
-            <a:avLst/>
-          </a:prstGeom>
-          <a:noFill/>
-          <a:ln/>
-        </p:spPr>
-        <p:txBody>
-          <a:bodyPr wrap="square" rtlCol="0" anchor="ctr"/>
-          <a:lstStyle/>
-          <a:p>
-            <a:pPr algn="r" indent="0" marL="0">
+              <a:t>Technology insights</a:t>
+            </a:r>
+            <a:endParaRPr lang="en-US" sz="1200" dirty="0"/>
+          </a:p>
+        </p:txBody>
+      </p:sp>
+      <p:sp>
+        <p:nvSpPr>
+          <p:cNvPr id="23" name="Text 21"/>
+          <p:cNvSpPr/>
+          <p:nvPr/>
+        </p:nvSpPr>
+        <p:spPr>
+          <a:xfrm>
+            <a:off x="4796028" y="3246120"/>
+            <a:ext cx="1620774" cy="384048"/>
+          </a:xfrm>
+          <a:prstGeom prst="rect">
+            <a:avLst/>
+          </a:prstGeom>
+          <a:noFill/>
+          <a:ln/>
+        </p:spPr>
+        <p:txBody>
+          <a:bodyPr wrap="square" rtlCol="0" anchor="b"/>
+          <a:lstStyle/>
+          <a:p>
+            <a:pPr algn="l" indent="0" marL="0">
               <a:buNone/>
             </a:pPr>
             <a:r>
-              <a:rPr lang="en-US" sz="900" i="1" dirty="0">
-                <a:solidFill>
-                  <a:srgbClr val="2C2C2A"/>
-                </a:solidFill>
-                <a:latin typeface="Inter" pitchFamily="34" charset="0"/>
-                <a:ea typeface="Inter" pitchFamily="34" charset="-122"/>
-                <a:cs typeface="Inter" pitchFamily="34" charset="-120"/>
-              </a:rPr>
-              <a:t>pełny</a:t>
-            </a:r>
-            <a:endParaRPr lang="en-US" sz="900" dirty="0"/>
-          </a:p>
-        </p:txBody>
-      </p:sp>
-      <p:sp>
-        <p:nvSpPr>
-          <p:cNvPr id="21" name="Shape 19"/>
-          <p:cNvSpPr/>
-          <p:nvPr/>
-        </p:nvSpPr>
-        <p:spPr>
-          <a:xfrm>
-            <a:off x="548640" y="3154680"/>
-            <a:ext cx="310896" cy="310896"/>
-          </a:xfrm>
-          <a:prstGeom prst="ellipse">
+              <a:rPr lang="en-US" sz="1000" i="1" dirty="0">
+                <a:solidFill>
+                  <a:srgbClr val="8A94A6"/>
+                </a:solidFill>
+                <a:latin typeface="Inter" pitchFamily="34" charset="0"/>
+                <a:ea typeface="Inter" pitchFamily="34" charset="-122"/>
+                <a:cs typeface="Inter" pitchFamily="34" charset="-120"/>
+              </a:rPr>
+              <a:t>mapped to 20 initiatives</a:t>
+            </a:r>
+            <a:endParaRPr lang="en-US" sz="1000" dirty="0"/>
+          </a:p>
+        </p:txBody>
+      </p:sp>
+      <p:sp>
+        <p:nvSpPr>
+          <p:cNvPr id="24" name="Shape 22"/>
+          <p:cNvSpPr/>
+          <p:nvPr/>
+        </p:nvSpPr>
+        <p:spPr>
+          <a:xfrm>
+            <a:off x="6755130" y="1554480"/>
+            <a:ext cx="1840230" cy="2148840"/>
+          </a:xfrm>
+          <a:prstGeom prst="rect">
             <a:avLst/>
           </a:prstGeom>
           <a:solidFill>
-            <a:srgbClr val="FFFFFF"/>
+            <a:srgbClr val="F5F8FC"/>
           </a:solidFill>
           <a:ln w="12700">
             <a:solidFill>
-              <a:srgbClr val="1D9E75"/>
+              <a:srgbClr val="E3E7EE"/>
             </a:solidFill>
             <a:prstDash val="solid"/>
           </a:ln>
@@ -5698,20 +6665,17 @@
       </p:sp>
       <p:sp>
         <p:nvSpPr>
-          <p:cNvPr id="22" name="Shape 20"/>
-          <p:cNvSpPr/>
-          <p:nvPr/>
-        </p:nvSpPr>
-        <p:spPr>
-          <a:xfrm>
-            <a:off x="548640" y="3154680"/>
-            <a:ext cx="310896" cy="310896"/>
-          </a:xfrm>
-          <a:prstGeom prst="pie">
-            <a:avLst>
-              <a:gd name="adj1" fmla="val 0"/>
-              <a:gd name="adj2" fmla="val 21600000"/>
-            </a:avLst>
+          <p:cNvPr id="25" name="Shape 23"/>
+          <p:cNvSpPr/>
+          <p:nvPr/>
+        </p:nvSpPr>
+        <p:spPr>
+          <a:xfrm>
+            <a:off x="6755130" y="1554480"/>
+            <a:ext cx="1840230" cy="64008"/>
+          </a:xfrm>
+          <a:prstGeom prst="rect">
+            <a:avLst/>
           </a:prstGeom>
           <a:solidFill>
             <a:srgbClr val="1D9E75"/>
@@ -5726,30 +6690,74 @@
       </p:sp>
       <p:sp>
         <p:nvSpPr>
-          <p:cNvPr id="23" name="Text 21"/>
-          <p:cNvSpPr/>
-          <p:nvPr/>
-        </p:nvSpPr>
-        <p:spPr>
-          <a:xfrm>
-            <a:off x="960120" y="3154680"/>
-            <a:ext cx="5943600" cy="365760"/>
-          </a:xfrm>
-          <a:prstGeom prst="rect">
-            <a:avLst/>
-          </a:prstGeom>
-          <a:noFill/>
-          <a:ln/>
-        </p:spPr>
-        <p:txBody>
-          <a:bodyPr wrap="square" rtlCol="0" anchor="ctr"/>
+          <p:cNvPr id="26" name="Text 24"/>
+          <p:cNvSpPr/>
+          <p:nvPr/>
+        </p:nvSpPr>
+        <p:spPr>
+          <a:xfrm>
+            <a:off x="6864858" y="1810512"/>
+            <a:ext cx="1620774" cy="868680"/>
+          </a:xfrm>
+          <a:prstGeom prst="rect">
+            <a:avLst/>
+          </a:prstGeom>
+          <a:noFill/>
+          <a:ln/>
+        </p:spPr>
+        <p:txBody>
+          <a:bodyPr wrap="square" rtlCol="0" anchor="t">
+            <a:normAutofit/>
+          </a:bodyPr>
           <a:lstStyle/>
           <a:p>
             <a:pPr algn="l" indent="0" marL="0">
               <a:buNone/>
             </a:pPr>
             <a:r>
-              <a:rPr lang="en-US" sz="1100" dirty="0">
+              <a:rPr lang="en-US" sz="3000" b="1" dirty="0">
+                <a:solidFill>
+                  <a:srgbClr val="0C447C"/>
+                </a:solidFill>
+                <a:latin typeface="Merriweather" pitchFamily="34" charset="0"/>
+                <a:ea typeface="Merriweather" pitchFamily="34" charset="-122"/>
+                <a:cs typeface="Merriweather" pitchFamily="34" charset="-120"/>
+              </a:rPr>
+              <a:t>+12 pp</a:t>
+            </a:r>
+            <a:endParaRPr lang="en-US" sz="3000" dirty="0"/>
+          </a:p>
+        </p:txBody>
+      </p:sp>
+      <p:sp>
+        <p:nvSpPr>
+          <p:cNvPr id="27" name="Text 25"/>
+          <p:cNvSpPr/>
+          <p:nvPr/>
+        </p:nvSpPr>
+        <p:spPr>
+          <a:xfrm>
+            <a:off x="6864858" y="2724912"/>
+            <a:ext cx="1620774" cy="640080"/>
+          </a:xfrm>
+          <a:prstGeom prst="rect">
+            <a:avLst/>
+          </a:prstGeom>
+          <a:noFill/>
+          <a:ln/>
+        </p:spPr>
+        <p:txBody>
+          <a:bodyPr wrap="square" rtlCol="0" anchor="t"/>
+          <a:lstStyle/>
+          <a:p>
+            <a:pPr algn="l" indent="0" marL="0">
+              <a:lnSpc>
+                <a:spcPct val="100000"/>
+              </a:lnSpc>
+              <a:buNone/>
+            </a:pPr>
+            <a:r>
+              <a:rPr lang="en-US" sz="1200" b="1" dirty="0">
                 <a:solidFill>
                   <a:srgbClr val="2C2C2A"/>
                 </a:solidFill>
@@ -5757,261 +6765,77 @@
                 <a:ea typeface="Inter" pitchFamily="34" charset="-122"/>
                 <a:cs typeface="Inter" pitchFamily="34" charset="-120"/>
               </a:rPr>
-              <a:t>Data governance (cross-portfolio)</a:t>
-            </a:r>
-            <a:endParaRPr lang="en-US" sz="1100" dirty="0"/>
-          </a:p>
-        </p:txBody>
-      </p:sp>
-      <p:sp>
-        <p:nvSpPr>
-          <p:cNvPr id="24" name="Text 22"/>
-          <p:cNvSpPr/>
-          <p:nvPr/>
-        </p:nvSpPr>
-        <p:spPr>
-          <a:xfrm>
-            <a:off x="6949440" y="3154680"/>
-            <a:ext cx="1645920" cy="365760"/>
-          </a:xfrm>
-          <a:prstGeom prst="rect">
-            <a:avLst/>
-          </a:prstGeom>
-          <a:noFill/>
-          <a:ln/>
-        </p:spPr>
-        <p:txBody>
-          <a:bodyPr wrap="square" rtlCol="0" anchor="ctr"/>
-          <a:lstStyle/>
-          <a:p>
-            <a:pPr algn="r" indent="0" marL="0">
-              <a:buNone/>
-            </a:pPr>
-            <a:r>
-              <a:rPr lang="en-US" sz="900" i="1" dirty="0">
-                <a:solidFill>
-                  <a:srgbClr val="2C2C2A"/>
-                </a:solidFill>
-                <a:latin typeface="Inter" pitchFamily="34" charset="0"/>
-                <a:ea typeface="Inter" pitchFamily="34" charset="-122"/>
-                <a:cs typeface="Inter" pitchFamily="34" charset="-120"/>
-              </a:rPr>
-              <a:t>pełny</a:t>
-            </a:r>
-            <a:endParaRPr lang="en-US" sz="900" dirty="0"/>
-          </a:p>
-        </p:txBody>
-      </p:sp>
-      <p:sp>
-        <p:nvSpPr>
-          <p:cNvPr id="25" name="Shape 23"/>
-          <p:cNvSpPr/>
-          <p:nvPr/>
-        </p:nvSpPr>
-        <p:spPr>
-          <a:xfrm>
-            <a:off x="548640" y="3566160"/>
-            <a:ext cx="310896" cy="310896"/>
-          </a:xfrm>
-          <a:prstGeom prst="ellipse">
-            <a:avLst/>
-          </a:prstGeom>
-          <a:solidFill>
-            <a:srgbClr val="FFFFFF"/>
-          </a:solidFill>
-          <a:ln w="12700">
-            <a:solidFill>
-              <a:srgbClr val="1D9E75"/>
-            </a:solidFill>
-            <a:prstDash val="solid"/>
-          </a:ln>
-        </p:spPr>
-      </p:sp>
-      <p:sp>
-        <p:nvSpPr>
-          <p:cNvPr id="26" name="Shape 24"/>
-          <p:cNvSpPr/>
-          <p:nvPr/>
-        </p:nvSpPr>
-        <p:spPr>
-          <a:xfrm>
-            <a:off x="548640" y="3566160"/>
-            <a:ext cx="310896" cy="310896"/>
-          </a:xfrm>
-          <a:prstGeom prst="pie">
-            <a:avLst>
-              <a:gd name="adj1" fmla="val 0"/>
-              <a:gd name="adj2" fmla="val 16200000"/>
-            </a:avLst>
-          </a:prstGeom>
-          <a:solidFill>
-            <a:srgbClr val="1D9E75"/>
-          </a:solidFill>
-          <a:ln w="12700">
-            <a:solidFill>
-              <a:srgbClr val="1D9E75"/>
-            </a:solidFill>
-            <a:prstDash val="solid"/>
-          </a:ln>
-        </p:spPr>
-      </p:sp>
-      <p:sp>
-        <p:nvSpPr>
-          <p:cNvPr id="27" name="Text 25"/>
-          <p:cNvSpPr/>
-          <p:nvPr/>
-        </p:nvSpPr>
-        <p:spPr>
-          <a:xfrm>
-            <a:off x="960120" y="3566160"/>
-            <a:ext cx="5943600" cy="365760"/>
-          </a:xfrm>
-          <a:prstGeom prst="rect">
-            <a:avLst/>
-          </a:prstGeom>
-          <a:noFill/>
-          <a:ln/>
-        </p:spPr>
-        <p:txBody>
-          <a:bodyPr wrap="square" rtlCol="0" anchor="ctr"/>
+              <a:t>Renewal-gap to top quartile</a:t>
+            </a:r>
+            <a:endParaRPr lang="en-US" sz="1200" dirty="0"/>
+          </a:p>
+        </p:txBody>
+      </p:sp>
+      <p:sp>
+        <p:nvSpPr>
+          <p:cNvPr id="28" name="Text 26"/>
+          <p:cNvSpPr/>
+          <p:nvPr/>
+        </p:nvSpPr>
+        <p:spPr>
+          <a:xfrm>
+            <a:off x="6864858" y="3246120"/>
+            <a:ext cx="1620774" cy="384048"/>
+          </a:xfrm>
+          <a:prstGeom prst="rect">
+            <a:avLst/>
+          </a:prstGeom>
+          <a:noFill/>
+          <a:ln/>
+        </p:spPr>
+        <p:txBody>
+          <a:bodyPr wrap="square" rtlCol="0" anchor="b"/>
           <a:lstStyle/>
           <a:p>
             <a:pPr algn="l" indent="0" marL="0">
               <a:buNone/>
             </a:pPr>
             <a:r>
-              <a:rPr lang="en-US" sz="1100" dirty="0">
-                <a:solidFill>
-                  <a:srgbClr val="2C2C2A"/>
-                </a:solidFill>
-                <a:latin typeface="Inter" pitchFamily="34" charset="0"/>
-                <a:ea typeface="Inter" pitchFamily="34" charset="-122"/>
-                <a:cs typeface="Inter" pitchFamily="34" charset="-120"/>
-              </a:rPr>
-              <a:t>Closed-loop quality</a:t>
-            </a:r>
-            <a:endParaRPr lang="en-US" sz="1100" dirty="0"/>
-          </a:p>
-        </p:txBody>
-      </p:sp>
-      <p:sp>
-        <p:nvSpPr>
-          <p:cNvPr id="28" name="Text 26"/>
-          <p:cNvSpPr/>
-          <p:nvPr/>
-        </p:nvSpPr>
-        <p:spPr>
-          <a:xfrm>
-            <a:off x="6949440" y="3566160"/>
-            <a:ext cx="1645920" cy="365760"/>
-          </a:xfrm>
-          <a:prstGeom prst="rect">
-            <a:avLst/>
-          </a:prstGeom>
-          <a:noFill/>
-          <a:ln/>
-        </p:spPr>
-        <p:txBody>
-          <a:bodyPr wrap="square" rtlCol="0" anchor="ctr"/>
-          <a:lstStyle/>
-          <a:p>
-            <a:pPr algn="r" indent="0" marL="0">
-              <a:buNone/>
-            </a:pPr>
-            <a:r>
-              <a:rPr lang="en-US" sz="900" i="1" dirty="0">
-                <a:solidFill>
-                  <a:srgbClr val="2C2C2A"/>
-                </a:solidFill>
-                <a:latin typeface="Inter" pitchFamily="34" charset="0"/>
-                <a:ea typeface="Inter" pitchFamily="34" charset="-122"/>
-                <a:cs typeface="Inter" pitchFamily="34" charset="-120"/>
-              </a:rPr>
-              <a:t>wysoki</a:t>
-            </a:r>
-            <a:endParaRPr lang="en-US" sz="900" dirty="0"/>
-          </a:p>
-        </p:txBody>
-      </p:sp>
-      <p:sp>
-        <p:nvSpPr>
-          <p:cNvPr id="29" name="Shape 27"/>
-          <p:cNvSpPr/>
-          <p:nvPr/>
-        </p:nvSpPr>
-        <p:spPr>
-          <a:xfrm>
-            <a:off x="548640" y="3977640"/>
-            <a:ext cx="310896" cy="310896"/>
-          </a:xfrm>
-          <a:prstGeom prst="ellipse">
-            <a:avLst/>
-          </a:prstGeom>
-          <a:solidFill>
-            <a:srgbClr val="FFFFFF"/>
-          </a:solidFill>
-          <a:ln w="12700">
-            <a:solidFill>
-              <a:srgbClr val="1D9E75"/>
-            </a:solidFill>
-            <a:prstDash val="solid"/>
-          </a:ln>
-        </p:spPr>
-      </p:sp>
-      <p:sp>
-        <p:nvSpPr>
-          <p:cNvPr id="30" name="Shape 28"/>
-          <p:cNvSpPr/>
-          <p:nvPr/>
-        </p:nvSpPr>
-        <p:spPr>
-          <a:xfrm>
-            <a:off x="548640" y="3977640"/>
-            <a:ext cx="310896" cy="310896"/>
-          </a:xfrm>
-          <a:prstGeom prst="pie">
-            <a:avLst>
-              <a:gd name="adj1" fmla="val 0"/>
-              <a:gd name="adj2" fmla="val 16200000"/>
-            </a:avLst>
-          </a:prstGeom>
-          <a:solidFill>
-            <a:srgbClr val="1D9E75"/>
-          </a:solidFill>
-          <a:ln w="12700">
-            <a:solidFill>
-              <a:srgbClr val="1D9E75"/>
-            </a:solidFill>
-            <a:prstDash val="solid"/>
-          </a:ln>
-        </p:spPr>
-      </p:sp>
-      <p:sp>
-        <p:nvSpPr>
-          <p:cNvPr id="31" name="Text 29"/>
-          <p:cNvSpPr/>
-          <p:nvPr/>
-        </p:nvSpPr>
-        <p:spPr>
-          <a:xfrm>
-            <a:off x="960120" y="3977640"/>
-            <a:ext cx="5943600" cy="365760"/>
-          </a:xfrm>
-          <a:prstGeom prst="rect">
-            <a:avLst/>
-          </a:prstGeom>
-          <a:noFill/>
-          <a:ln/>
-        </p:spPr>
-        <p:txBody>
-          <a:bodyPr wrap="square" rtlCol="0" anchor="ctr"/>
+              <a:rPr lang="en-US" sz="1000" i="1" dirty="0">
+                <a:solidFill>
+                  <a:srgbClr val="8A94A6"/>
+                </a:solidFill>
+                <a:latin typeface="Inter" pitchFamily="34" charset="0"/>
+                <a:ea typeface="Inter" pitchFamily="34" charset="-122"/>
+                <a:cs typeface="Inter" pitchFamily="34" charset="-120"/>
+              </a:rPr>
+              <a:t>76–80% → 88–92%</a:t>
+            </a:r>
+            <a:endParaRPr lang="en-US" sz="1000" dirty="0"/>
+          </a:p>
+        </p:txBody>
+      </p:sp>
+      <p:sp>
+        <p:nvSpPr>
+          <p:cNvPr id="29" name="Text 27"/>
+          <p:cNvSpPr/>
+          <p:nvPr/>
+        </p:nvSpPr>
+        <p:spPr>
+          <a:xfrm>
+            <a:off x="548640" y="3886200"/>
+            <a:ext cx="8046720" cy="822960"/>
+          </a:xfrm>
+          <a:prstGeom prst="rect">
+            <a:avLst/>
+          </a:prstGeom>
+          <a:noFill/>
+          <a:ln/>
+        </p:spPr>
+        <p:txBody>
+          <a:bodyPr wrap="square" rtlCol="0" anchor="t"/>
           <a:lstStyle/>
           <a:p>
             <a:pPr algn="l" indent="0" marL="0">
               <a:buNone/>
             </a:pPr>
             <a:r>
-              <a:rPr lang="en-US" sz="1100" dirty="0">
+              <a:rPr lang="en-US" sz="1200" dirty="0">
                 <a:solidFill>
                   <a:srgbClr val="2C2C2A"/>
                 </a:solidFill>
@@ -6019,218 +6843,9 @@
                 <a:ea typeface="Inter" pitchFamily="34" charset="-122"/>
                 <a:cs typeface="Inter" pitchFamily="34" charset="-120"/>
               </a:rPr>
-              <a:t>OT cybersecurity</a:t>
-            </a:r>
-            <a:endParaRPr lang="en-US" sz="1100" dirty="0"/>
-          </a:p>
-        </p:txBody>
-      </p:sp>
-      <p:sp>
-        <p:nvSpPr>
-          <p:cNvPr id="32" name="Text 30"/>
-          <p:cNvSpPr/>
-          <p:nvPr/>
-        </p:nvSpPr>
-        <p:spPr>
-          <a:xfrm>
-            <a:off x="6949440" y="3977640"/>
-            <a:ext cx="1645920" cy="365760"/>
-          </a:xfrm>
-          <a:prstGeom prst="rect">
-            <a:avLst/>
-          </a:prstGeom>
-          <a:noFill/>
-          <a:ln/>
-        </p:spPr>
-        <p:txBody>
-          <a:bodyPr wrap="square" rtlCol="0" anchor="ctr"/>
-          <a:lstStyle/>
-          <a:p>
-            <a:pPr algn="r" indent="0" marL="0">
-              <a:buNone/>
-            </a:pPr>
-            <a:r>
-              <a:rPr lang="en-US" sz="900" i="1" dirty="0">
-                <a:solidFill>
-                  <a:srgbClr val="2C2C2A"/>
-                </a:solidFill>
-                <a:latin typeface="Inter" pitchFamily="34" charset="0"/>
-                <a:ea typeface="Inter" pitchFamily="34" charset="-122"/>
-                <a:cs typeface="Inter" pitchFamily="34" charset="-120"/>
-              </a:rPr>
-              <a:t>wysoki</a:t>
-            </a:r>
-            <a:endParaRPr lang="en-US" sz="900" dirty="0"/>
-          </a:p>
-        </p:txBody>
-      </p:sp>
-      <p:sp>
-        <p:nvSpPr>
-          <p:cNvPr id="33" name="Shape 31"/>
-          <p:cNvSpPr/>
-          <p:nvPr/>
-        </p:nvSpPr>
-        <p:spPr>
-          <a:xfrm>
-            <a:off x="548640" y="4389120"/>
-            <a:ext cx="310896" cy="310896"/>
-          </a:xfrm>
-          <a:prstGeom prst="ellipse">
-            <a:avLst/>
-          </a:prstGeom>
-          <a:solidFill>
-            <a:srgbClr val="FFFFFF"/>
-          </a:solidFill>
-          <a:ln w="12700">
-            <a:solidFill>
-              <a:srgbClr val="1D9E75"/>
-            </a:solidFill>
-            <a:prstDash val="solid"/>
-          </a:ln>
-        </p:spPr>
-      </p:sp>
-      <p:sp>
-        <p:nvSpPr>
-          <p:cNvPr id="34" name="Shape 32"/>
-          <p:cNvSpPr/>
-          <p:nvPr/>
-        </p:nvSpPr>
-        <p:spPr>
-          <a:xfrm>
-            <a:off x="548640" y="4389120"/>
-            <a:ext cx="310896" cy="310896"/>
-          </a:xfrm>
-          <a:prstGeom prst="pie">
-            <a:avLst>
-              <a:gd name="adj1" fmla="val 0"/>
-              <a:gd name="adj2" fmla="val 10800000"/>
-            </a:avLst>
-          </a:prstGeom>
-          <a:solidFill>
-            <a:srgbClr val="1D9E75"/>
-          </a:solidFill>
-          <a:ln w="12700">
-            <a:solidFill>
-              <a:srgbClr val="1D9E75"/>
-            </a:solidFill>
-            <a:prstDash val="solid"/>
-          </a:ln>
-        </p:spPr>
-      </p:sp>
-      <p:sp>
-        <p:nvSpPr>
-          <p:cNvPr id="35" name="Text 33"/>
-          <p:cNvSpPr/>
-          <p:nvPr/>
-        </p:nvSpPr>
-        <p:spPr>
-          <a:xfrm>
-            <a:off x="960120" y="4389120"/>
-            <a:ext cx="5943600" cy="365760"/>
-          </a:xfrm>
-          <a:prstGeom prst="rect">
-            <a:avLst/>
-          </a:prstGeom>
-          <a:noFill/>
-          <a:ln/>
-        </p:spPr>
-        <p:txBody>
-          <a:bodyPr wrap="square" rtlCol="0" anchor="ctr"/>
-          <a:lstStyle/>
-          <a:p>
-            <a:pPr algn="l" indent="0" marL="0">
-              <a:buNone/>
-            </a:pPr>
-            <a:r>
-              <a:rPr lang="en-US" sz="1100" dirty="0">
-                <a:solidFill>
-                  <a:srgbClr val="2C2C2A"/>
-                </a:solidFill>
-                <a:latin typeface="Inter" pitchFamily="34" charset="0"/>
-                <a:ea typeface="Inter" pitchFamily="34" charset="-122"/>
-                <a:cs typeface="Inter" pitchFamily="34" charset="-120"/>
-              </a:rPr>
-              <a:t>Partner activation</a:t>
-            </a:r>
-            <a:endParaRPr lang="en-US" sz="1100" dirty="0"/>
-          </a:p>
-        </p:txBody>
-      </p:sp>
-      <p:sp>
-        <p:nvSpPr>
-          <p:cNvPr id="36" name="Text 34"/>
-          <p:cNvSpPr/>
-          <p:nvPr/>
-        </p:nvSpPr>
-        <p:spPr>
-          <a:xfrm>
-            <a:off x="6949440" y="4389120"/>
-            <a:ext cx="1645920" cy="365760"/>
-          </a:xfrm>
-          <a:prstGeom prst="rect">
-            <a:avLst/>
-          </a:prstGeom>
-          <a:noFill/>
-          <a:ln/>
-        </p:spPr>
-        <p:txBody>
-          <a:bodyPr wrap="square" rtlCol="0" anchor="ctr"/>
-          <a:lstStyle/>
-          <a:p>
-            <a:pPr algn="r" indent="0" marL="0">
-              <a:buNone/>
-            </a:pPr>
-            <a:r>
-              <a:rPr lang="en-US" sz="900" i="1" dirty="0">
-                <a:solidFill>
-                  <a:srgbClr val="2C2C2A"/>
-                </a:solidFill>
-                <a:latin typeface="Inter" pitchFamily="34" charset="0"/>
-                <a:ea typeface="Inter" pitchFamily="34" charset="-122"/>
-                <a:cs typeface="Inter" pitchFamily="34" charset="-120"/>
-              </a:rPr>
-              <a:t>średni</a:t>
-            </a:r>
-            <a:endParaRPr lang="en-US" sz="900" dirty="0"/>
-          </a:p>
-        </p:txBody>
-      </p:sp>
-      <p:sp>
-        <p:nvSpPr>
-          <p:cNvPr id="37" name="Text 35"/>
-          <p:cNvSpPr/>
-          <p:nvPr/>
-        </p:nvSpPr>
-        <p:spPr>
-          <a:xfrm>
-            <a:off x="548640" y="1463040"/>
-            <a:ext cx="8046720" cy="411480"/>
-          </a:xfrm>
-          <a:prstGeom prst="rect">
-            <a:avLst/>
-          </a:prstGeom>
-          <a:noFill/>
-          <a:ln/>
-        </p:spPr>
-        <p:txBody>
-          <a:bodyPr wrap="square" rtlCol="0" anchor="t"/>
-          <a:lstStyle/>
-          <a:p>
-            <a:pPr algn="l" indent="0" marL="0">
-              <a:buNone/>
-            </a:pPr>
-            <a:r>
-              <a:rPr lang="en-US" sz="1100" dirty="0">
-                <a:solidFill>
-                  <a:srgbClr val="2C2C2A"/>
-                </a:solidFill>
-                <a:latin typeface="Inter" pitchFamily="34" charset="0"/>
-                <a:ea typeface="Inter" pitchFamily="34" charset="-122"/>
-                <a:cs typeface="Inter" pitchFamily="34" charset="-120"/>
-              </a:rPr>
-              <a:t>Start where evidence is strong, the value pool is material, and named owners already exist — do not wait for a perfect maturity audit before launching the first wave.</a:t>
-            </a:r>
-            <a:endParaRPr lang="en-US" sz="1100" dirty="0"/>
+              <a:t>Four numbers frame the mandate: a deep evidence base, a large but concentrated value pool, and a renewal gap that alone protects the biggest single pool.</a:t>
+            </a:r>
+            <a:endParaRPr lang="en-US" sz="1200" dirty="0"/>
           </a:p>
         </p:txBody>
       </p:sp>
@@ -6329,7 +6944,7 @@
                 <a:ea typeface="Merriweather" pitchFamily="34" charset="-122"/>
                 <a:cs typeface="Merriweather" pitchFamily="34" charset="-120"/>
               </a:rPr>
-              <a:t>Factory telemetry is rich, but supervisors react 30 minutes after the loss</a:t>
+              <a:t>The executive heatmap sequences Wave 1 where evidence and value both concentrate</a:t>
             </a:r>
             <a:endParaRPr lang="en-US" sz="3000" dirty="0"/>
           </a:p>
@@ -6496,7 +7111,7 @@
                 <a:ea typeface="Inter" pitchFamily="34" charset="-122"/>
                 <a:cs typeface="Inter" pitchFamily="34" charset="-120"/>
               </a:rPr>
-              <a:t>SOLUTION</a:t>
+              <a:t>RISK</a:t>
             </a:r>
             <a:endParaRPr lang="en-US" sz="700" dirty="0"/>
           </a:p>
@@ -6504,36 +7119,83 @@
       </p:sp>
       <p:sp>
         <p:nvSpPr>
-          <p:cNvPr id="9" name="Text 7"/>
-          <p:cNvSpPr/>
-          <p:nvPr/>
-        </p:nvSpPr>
-        <p:spPr>
-          <a:xfrm>
-            <a:off x="548640" y="1554480"/>
-            <a:ext cx="8046720" cy="3017520"/>
-          </a:xfrm>
-          <a:prstGeom prst="rect">
-            <a:avLst/>
-          </a:prstGeom>
-          <a:noFill/>
-          <a:ln/>
-        </p:spPr>
-        <p:txBody>
-          <a:bodyPr wrap="square" rtlCol="0" anchor="t">
-            <a:normAutofit/>
-          </a:bodyPr>
-          <a:lstStyle/>
-          <a:p>
-            <a:pPr algn="l" marL="228600" indent="-228600">
-              <a:spcAft>
-                <a:spcPts val="800"/>
-              </a:spcAft>
-              <a:buSzPct val="100000"/>
-              <a:buChar char="▪"/>
-            </a:pPr>
-            <a:r>
-              <a:rPr lang="en-US" sz="2000" dirty="0">
+          <p:cNvPr id="9" name="Shape 7"/>
+          <p:cNvSpPr/>
+          <p:nvPr/>
+        </p:nvSpPr>
+        <p:spPr>
+          <a:xfrm>
+            <a:off x="548640" y="1920240"/>
+            <a:ext cx="310896" cy="310896"/>
+          </a:xfrm>
+          <a:prstGeom prst="ellipse">
+            <a:avLst/>
+          </a:prstGeom>
+          <a:solidFill>
+            <a:srgbClr val="FFFFFF"/>
+          </a:solidFill>
+          <a:ln w="12700">
+            <a:solidFill>
+              <a:srgbClr val="1D9E75"/>
+            </a:solidFill>
+            <a:prstDash val="solid"/>
+          </a:ln>
+        </p:spPr>
+      </p:sp>
+      <p:sp>
+        <p:nvSpPr>
+          <p:cNvPr id="10" name="Shape 8"/>
+          <p:cNvSpPr/>
+          <p:nvPr/>
+        </p:nvSpPr>
+        <p:spPr>
+          <a:xfrm>
+            <a:off x="548640" y="1920240"/>
+            <a:ext cx="310896" cy="310896"/>
+          </a:xfrm>
+          <a:prstGeom prst="pie">
+            <a:avLst>
+              <a:gd name="adj1" fmla="val 0"/>
+              <a:gd name="adj2" fmla="val 21600000"/>
+            </a:avLst>
+          </a:prstGeom>
+          <a:solidFill>
+            <a:srgbClr val="1D9E75"/>
+          </a:solidFill>
+          <a:ln w="12700">
+            <a:solidFill>
+              <a:srgbClr val="1D9E75"/>
+            </a:solidFill>
+            <a:prstDash val="solid"/>
+          </a:ln>
+        </p:spPr>
+      </p:sp>
+      <p:sp>
+        <p:nvSpPr>
+          <p:cNvPr id="11" name="Text 9"/>
+          <p:cNvSpPr/>
+          <p:nvPr/>
+        </p:nvSpPr>
+        <p:spPr>
+          <a:xfrm>
+            <a:off x="960120" y="1920240"/>
+            <a:ext cx="5943600" cy="365760"/>
+          </a:xfrm>
+          <a:prstGeom prst="rect">
+            <a:avLst/>
+          </a:prstGeom>
+          <a:noFill/>
+          <a:ln/>
+        </p:spPr>
+        <p:txBody>
+          <a:bodyPr wrap="square" rtlCol="0" anchor="ctr"/>
+          <a:lstStyle/>
+          <a:p>
+            <a:pPr algn="l" indent="0" marL="0">
+              <a:buNone/>
+            </a:pPr>
+            <a:r>
+              <a:rPr lang="en-US" sz="1100" dirty="0">
                 <a:solidFill>
                   <a:srgbClr val="2C2C2A"/>
                 </a:solidFill>
@@ -6541,17 +7203,38 @@
                 <a:ea typeface="Inter" pitchFamily="34" charset="-122"/>
                 <a:cs typeface="Inter" pitchFamily="34" charset="-120"/>
               </a:rPr>
-              <a:t>Decision required: approve a Line 3 shift-decision contract</a:t>
-            </a:r>
-            <a:pPr algn="l" marL="228600" indent="-228600">
-              <a:spcAft>
-                <a:spcPts val="800"/>
-              </a:spcAft>
-              <a:buSzPct val="100000"/>
-              <a:buChar char="▪"/>
-            </a:pPr>
-            <a:r>
-              <a:rPr lang="en-US" sz="2000" dirty="0">
+              <a:t>Factory telemetry &amp; Digital Twin</a:t>
+            </a:r>
+            <a:endParaRPr lang="en-US" sz="1100" dirty="0"/>
+          </a:p>
+        </p:txBody>
+      </p:sp>
+      <p:sp>
+        <p:nvSpPr>
+          <p:cNvPr id="12" name="Text 10"/>
+          <p:cNvSpPr/>
+          <p:nvPr/>
+        </p:nvSpPr>
+        <p:spPr>
+          <a:xfrm>
+            <a:off x="6949440" y="1920240"/>
+            <a:ext cx="1645920" cy="365760"/>
+          </a:xfrm>
+          <a:prstGeom prst="rect">
+            <a:avLst/>
+          </a:prstGeom>
+          <a:noFill/>
+          <a:ln/>
+        </p:spPr>
+        <p:txBody>
+          <a:bodyPr wrap="square" rtlCol="0" anchor="ctr"/>
+          <a:lstStyle/>
+          <a:p>
+            <a:pPr algn="r" indent="0" marL="0">
+              <a:buNone/>
+            </a:pPr>
+            <a:r>
+              <a:rPr lang="en-US" sz="900" i="1" dirty="0">
                 <a:solidFill>
                   <a:srgbClr val="2C2C2A"/>
                 </a:solidFill>
@@ -6559,17 +7242,91 @@
                 <a:ea typeface="Inter" pitchFamily="34" charset="-122"/>
                 <a:cs typeface="Inter" pitchFamily="34" charset="-120"/>
               </a:rPr>
-              <a:t>Event taxonomy + alert routing + action protocol…</a:t>
-            </a:r>
-            <a:pPr algn="l" marL="228600" indent="-228600">
-              <a:spcAft>
-                <a:spcPts val="800"/>
-              </a:spcAft>
-              <a:buSzPct val="100000"/>
-              <a:buChar char="▪"/>
-            </a:pPr>
-            <a:r>
-              <a:rPr lang="en-US" sz="2000" dirty="0">
+              <a:t>pełny</a:t>
+            </a:r>
+            <a:endParaRPr lang="en-US" sz="900" dirty="0"/>
+          </a:p>
+        </p:txBody>
+      </p:sp>
+      <p:sp>
+        <p:nvSpPr>
+          <p:cNvPr id="13" name="Shape 11"/>
+          <p:cNvSpPr/>
+          <p:nvPr/>
+        </p:nvSpPr>
+        <p:spPr>
+          <a:xfrm>
+            <a:off x="548640" y="2331720"/>
+            <a:ext cx="310896" cy="310896"/>
+          </a:xfrm>
+          <a:prstGeom prst="ellipse">
+            <a:avLst/>
+          </a:prstGeom>
+          <a:solidFill>
+            <a:srgbClr val="FFFFFF"/>
+          </a:solidFill>
+          <a:ln w="12700">
+            <a:solidFill>
+              <a:srgbClr val="1D9E75"/>
+            </a:solidFill>
+            <a:prstDash val="solid"/>
+          </a:ln>
+        </p:spPr>
+      </p:sp>
+      <p:sp>
+        <p:nvSpPr>
+          <p:cNvPr id="14" name="Shape 12"/>
+          <p:cNvSpPr/>
+          <p:nvPr/>
+        </p:nvSpPr>
+        <p:spPr>
+          <a:xfrm>
+            <a:off x="548640" y="2331720"/>
+            <a:ext cx="310896" cy="310896"/>
+          </a:xfrm>
+          <a:prstGeom prst="pie">
+            <a:avLst>
+              <a:gd name="adj1" fmla="val 0"/>
+              <a:gd name="adj2" fmla="val 21600000"/>
+            </a:avLst>
+          </a:prstGeom>
+          <a:solidFill>
+            <a:srgbClr val="1D9E75"/>
+          </a:solidFill>
+          <a:ln w="12700">
+            <a:solidFill>
+              <a:srgbClr val="1D9E75"/>
+            </a:solidFill>
+            <a:prstDash val="solid"/>
+          </a:ln>
+        </p:spPr>
+      </p:sp>
+      <p:sp>
+        <p:nvSpPr>
+          <p:cNvPr id="15" name="Text 13"/>
+          <p:cNvSpPr/>
+          <p:nvPr/>
+        </p:nvSpPr>
+        <p:spPr>
+          <a:xfrm>
+            <a:off x="960120" y="2331720"/>
+            <a:ext cx="5943600" cy="365760"/>
+          </a:xfrm>
+          <a:prstGeom prst="rect">
+            <a:avLst/>
+          </a:prstGeom>
+          <a:noFill/>
+          <a:ln/>
+        </p:spPr>
+        <p:txBody>
+          <a:bodyPr wrap="square" rtlCol="0" anchor="ctr"/>
+          <a:lstStyle/>
+          <a:p>
+            <a:pPr algn="l" indent="0" marL="0">
+              <a:buNone/>
+            </a:pPr>
+            <a:r>
+              <a:rPr lang="en-US" sz="1100" dirty="0">
                 <a:solidFill>
                   <a:srgbClr val="2C2C2A"/>
                 </a:solidFill>
@@ -6577,17 +7334,38 @@
                 <a:ea typeface="Inter" pitchFamily="34" charset="-122"/>
                 <a:cs typeface="Inter" pitchFamily="34" charset="-120"/>
               </a:rPr>
-              <a:t>Fund Digital Twin as an operating system, not…</a:t>
-            </a:r>
-            <a:pPr algn="l" marL="228600" indent="-228600">
-              <a:spcAft>
-                <a:spcPts val="800"/>
-              </a:spcAft>
-              <a:buSzPct val="100000"/>
-              <a:buChar char="▪"/>
-            </a:pPr>
-            <a:r>
-              <a:rPr lang="en-US" sz="2000" dirty="0">
+              <a:t>Supplier control tower</a:t>
+            </a:r>
+            <a:endParaRPr lang="en-US" sz="1100" dirty="0"/>
+          </a:p>
+        </p:txBody>
+      </p:sp>
+      <p:sp>
+        <p:nvSpPr>
+          <p:cNvPr id="16" name="Text 14"/>
+          <p:cNvSpPr/>
+          <p:nvPr/>
+        </p:nvSpPr>
+        <p:spPr>
+          <a:xfrm>
+            <a:off x="6949440" y="2331720"/>
+            <a:ext cx="1645920" cy="365760"/>
+          </a:xfrm>
+          <a:prstGeom prst="rect">
+            <a:avLst/>
+          </a:prstGeom>
+          <a:noFill/>
+          <a:ln/>
+        </p:spPr>
+        <p:txBody>
+          <a:bodyPr wrap="square" rtlCol="0" anchor="ctr"/>
+          <a:lstStyle/>
+          <a:p>
+            <a:pPr algn="r" indent="0" marL="0">
+              <a:buNone/>
+            </a:pPr>
+            <a:r>
+              <a:rPr lang="en-US" sz="900" i="1" dirty="0">
                 <a:solidFill>
                   <a:srgbClr val="2C2C2A"/>
                 </a:solidFill>
@@ -6595,9 +7373,703 @@
                 <a:ea typeface="Inter" pitchFamily="34" charset="-122"/>
                 <a:cs typeface="Inter" pitchFamily="34" charset="-120"/>
               </a:rPr>
-              <a:t>Adoption KPIs sit next to outcome KPIs</a:t>
-            </a:r>
-            <a:endParaRPr lang="en-US" sz="2000" dirty="0"/>
+              <a:t>pełny</a:t>
+            </a:r>
+            <a:endParaRPr lang="en-US" sz="900" dirty="0"/>
+          </a:p>
+        </p:txBody>
+      </p:sp>
+      <p:sp>
+        <p:nvSpPr>
+          <p:cNvPr id="17" name="Shape 15"/>
+          <p:cNvSpPr/>
+          <p:nvPr/>
+        </p:nvSpPr>
+        <p:spPr>
+          <a:xfrm>
+            <a:off x="548640" y="2743200"/>
+            <a:ext cx="310896" cy="310896"/>
+          </a:xfrm>
+          <a:prstGeom prst="ellipse">
+            <a:avLst/>
+          </a:prstGeom>
+          <a:solidFill>
+            <a:srgbClr val="FFFFFF"/>
+          </a:solidFill>
+          <a:ln w="12700">
+            <a:solidFill>
+              <a:srgbClr val="1D9E75"/>
+            </a:solidFill>
+            <a:prstDash val="solid"/>
+          </a:ln>
+        </p:spPr>
+      </p:sp>
+      <p:sp>
+        <p:nvSpPr>
+          <p:cNvPr id="18" name="Shape 16"/>
+          <p:cNvSpPr/>
+          <p:nvPr/>
+        </p:nvSpPr>
+        <p:spPr>
+          <a:xfrm>
+            <a:off x="548640" y="2743200"/>
+            <a:ext cx="310896" cy="310896"/>
+          </a:xfrm>
+          <a:prstGeom prst="pie">
+            <a:avLst>
+              <a:gd name="adj1" fmla="val 0"/>
+              <a:gd name="adj2" fmla="val 21600000"/>
+            </a:avLst>
+          </a:prstGeom>
+          <a:solidFill>
+            <a:srgbClr val="1D9E75"/>
+          </a:solidFill>
+          <a:ln w="12700">
+            <a:solidFill>
+              <a:srgbClr val="1D9E75"/>
+            </a:solidFill>
+            <a:prstDash val="solid"/>
+          </a:ln>
+        </p:spPr>
+      </p:sp>
+      <p:sp>
+        <p:nvSpPr>
+          <p:cNvPr id="19" name="Text 17"/>
+          <p:cNvSpPr/>
+          <p:nvPr/>
+        </p:nvSpPr>
+        <p:spPr>
+          <a:xfrm>
+            <a:off x="960120" y="2743200"/>
+            <a:ext cx="5943600" cy="365760"/>
+          </a:xfrm>
+          <a:prstGeom prst="rect">
+            <a:avLst/>
+          </a:prstGeom>
+          <a:noFill/>
+          <a:ln/>
+        </p:spPr>
+        <p:txBody>
+          <a:bodyPr wrap="square" rtlCol="0" anchor="ctr"/>
+          <a:lstStyle/>
+          <a:p>
+            <a:pPr algn="l" indent="0" marL="0">
+              <a:buNone/>
+            </a:pPr>
+            <a:r>
+              <a:rPr lang="en-US" sz="1100" dirty="0">
+                <a:solidFill>
+                  <a:srgbClr val="2C2C2A"/>
+                </a:solidFill>
+                <a:latin typeface="Inter" pitchFamily="34" charset="0"/>
+                <a:ea typeface="Inter" pitchFamily="34" charset="-122"/>
+                <a:cs typeface="Inter" pitchFamily="34" charset="-120"/>
+              </a:rPr>
+              <a:t>Digital subscription renewal risk</a:t>
+            </a:r>
+            <a:endParaRPr lang="en-US" sz="1100" dirty="0"/>
+          </a:p>
+        </p:txBody>
+      </p:sp>
+      <p:sp>
+        <p:nvSpPr>
+          <p:cNvPr id="20" name="Text 18"/>
+          <p:cNvSpPr/>
+          <p:nvPr/>
+        </p:nvSpPr>
+        <p:spPr>
+          <a:xfrm>
+            <a:off x="6949440" y="2743200"/>
+            <a:ext cx="1645920" cy="365760"/>
+          </a:xfrm>
+          <a:prstGeom prst="rect">
+            <a:avLst/>
+          </a:prstGeom>
+          <a:noFill/>
+          <a:ln/>
+        </p:spPr>
+        <p:txBody>
+          <a:bodyPr wrap="square" rtlCol="0" anchor="ctr"/>
+          <a:lstStyle/>
+          <a:p>
+            <a:pPr algn="r" indent="0" marL="0">
+              <a:buNone/>
+            </a:pPr>
+            <a:r>
+              <a:rPr lang="en-US" sz="900" i="1" dirty="0">
+                <a:solidFill>
+                  <a:srgbClr val="2C2C2A"/>
+                </a:solidFill>
+                <a:latin typeface="Inter" pitchFamily="34" charset="0"/>
+                <a:ea typeface="Inter" pitchFamily="34" charset="-122"/>
+                <a:cs typeface="Inter" pitchFamily="34" charset="-120"/>
+              </a:rPr>
+              <a:t>pełny</a:t>
+            </a:r>
+            <a:endParaRPr lang="en-US" sz="900" dirty="0"/>
+          </a:p>
+        </p:txBody>
+      </p:sp>
+      <p:sp>
+        <p:nvSpPr>
+          <p:cNvPr id="21" name="Shape 19"/>
+          <p:cNvSpPr/>
+          <p:nvPr/>
+        </p:nvSpPr>
+        <p:spPr>
+          <a:xfrm>
+            <a:off x="548640" y="3154680"/>
+            <a:ext cx="310896" cy="310896"/>
+          </a:xfrm>
+          <a:prstGeom prst="ellipse">
+            <a:avLst/>
+          </a:prstGeom>
+          <a:solidFill>
+            <a:srgbClr val="FFFFFF"/>
+          </a:solidFill>
+          <a:ln w="12700">
+            <a:solidFill>
+              <a:srgbClr val="1D9E75"/>
+            </a:solidFill>
+            <a:prstDash val="solid"/>
+          </a:ln>
+        </p:spPr>
+      </p:sp>
+      <p:sp>
+        <p:nvSpPr>
+          <p:cNvPr id="22" name="Shape 20"/>
+          <p:cNvSpPr/>
+          <p:nvPr/>
+        </p:nvSpPr>
+        <p:spPr>
+          <a:xfrm>
+            <a:off x="548640" y="3154680"/>
+            <a:ext cx="310896" cy="310896"/>
+          </a:xfrm>
+          <a:prstGeom prst="pie">
+            <a:avLst>
+              <a:gd name="adj1" fmla="val 0"/>
+              <a:gd name="adj2" fmla="val 21600000"/>
+            </a:avLst>
+          </a:prstGeom>
+          <a:solidFill>
+            <a:srgbClr val="1D9E75"/>
+          </a:solidFill>
+          <a:ln w="12700">
+            <a:solidFill>
+              <a:srgbClr val="1D9E75"/>
+            </a:solidFill>
+            <a:prstDash val="solid"/>
+          </a:ln>
+        </p:spPr>
+      </p:sp>
+      <p:sp>
+        <p:nvSpPr>
+          <p:cNvPr id="23" name="Text 21"/>
+          <p:cNvSpPr/>
+          <p:nvPr/>
+        </p:nvSpPr>
+        <p:spPr>
+          <a:xfrm>
+            <a:off x="960120" y="3154680"/>
+            <a:ext cx="5943600" cy="365760"/>
+          </a:xfrm>
+          <a:prstGeom prst="rect">
+            <a:avLst/>
+          </a:prstGeom>
+          <a:noFill/>
+          <a:ln/>
+        </p:spPr>
+        <p:txBody>
+          <a:bodyPr wrap="square" rtlCol="0" anchor="ctr"/>
+          <a:lstStyle/>
+          <a:p>
+            <a:pPr algn="l" indent="0" marL="0">
+              <a:buNone/>
+            </a:pPr>
+            <a:r>
+              <a:rPr lang="en-US" sz="1100" dirty="0">
+                <a:solidFill>
+                  <a:srgbClr val="2C2C2A"/>
+                </a:solidFill>
+                <a:latin typeface="Inter" pitchFamily="34" charset="0"/>
+                <a:ea typeface="Inter" pitchFamily="34" charset="-122"/>
+                <a:cs typeface="Inter" pitchFamily="34" charset="-120"/>
+              </a:rPr>
+              <a:t>Data governance (cross-portfolio)</a:t>
+            </a:r>
+            <a:endParaRPr lang="en-US" sz="1100" dirty="0"/>
+          </a:p>
+        </p:txBody>
+      </p:sp>
+      <p:sp>
+        <p:nvSpPr>
+          <p:cNvPr id="24" name="Text 22"/>
+          <p:cNvSpPr/>
+          <p:nvPr/>
+        </p:nvSpPr>
+        <p:spPr>
+          <a:xfrm>
+            <a:off x="6949440" y="3154680"/>
+            <a:ext cx="1645920" cy="365760"/>
+          </a:xfrm>
+          <a:prstGeom prst="rect">
+            <a:avLst/>
+          </a:prstGeom>
+          <a:noFill/>
+          <a:ln/>
+        </p:spPr>
+        <p:txBody>
+          <a:bodyPr wrap="square" rtlCol="0" anchor="ctr"/>
+          <a:lstStyle/>
+          <a:p>
+            <a:pPr algn="r" indent="0" marL="0">
+              <a:buNone/>
+            </a:pPr>
+            <a:r>
+              <a:rPr lang="en-US" sz="900" i="1" dirty="0">
+                <a:solidFill>
+                  <a:srgbClr val="2C2C2A"/>
+                </a:solidFill>
+                <a:latin typeface="Inter" pitchFamily="34" charset="0"/>
+                <a:ea typeface="Inter" pitchFamily="34" charset="-122"/>
+                <a:cs typeface="Inter" pitchFamily="34" charset="-120"/>
+              </a:rPr>
+              <a:t>pełny</a:t>
+            </a:r>
+            <a:endParaRPr lang="en-US" sz="900" dirty="0"/>
+          </a:p>
+        </p:txBody>
+      </p:sp>
+      <p:sp>
+        <p:nvSpPr>
+          <p:cNvPr id="25" name="Shape 23"/>
+          <p:cNvSpPr/>
+          <p:nvPr/>
+        </p:nvSpPr>
+        <p:spPr>
+          <a:xfrm>
+            <a:off x="548640" y="3566160"/>
+            <a:ext cx="310896" cy="310896"/>
+          </a:xfrm>
+          <a:prstGeom prst="ellipse">
+            <a:avLst/>
+          </a:prstGeom>
+          <a:solidFill>
+            <a:srgbClr val="FFFFFF"/>
+          </a:solidFill>
+          <a:ln w="12700">
+            <a:solidFill>
+              <a:srgbClr val="1D9E75"/>
+            </a:solidFill>
+            <a:prstDash val="solid"/>
+          </a:ln>
+        </p:spPr>
+      </p:sp>
+      <p:sp>
+        <p:nvSpPr>
+          <p:cNvPr id="26" name="Shape 24"/>
+          <p:cNvSpPr/>
+          <p:nvPr/>
+        </p:nvSpPr>
+        <p:spPr>
+          <a:xfrm>
+            <a:off x="548640" y="3566160"/>
+            <a:ext cx="310896" cy="310896"/>
+          </a:xfrm>
+          <a:prstGeom prst="pie">
+            <a:avLst>
+              <a:gd name="adj1" fmla="val 0"/>
+              <a:gd name="adj2" fmla="val 16200000"/>
+            </a:avLst>
+          </a:prstGeom>
+          <a:solidFill>
+            <a:srgbClr val="1D9E75"/>
+          </a:solidFill>
+          <a:ln w="12700">
+            <a:solidFill>
+              <a:srgbClr val="1D9E75"/>
+            </a:solidFill>
+            <a:prstDash val="solid"/>
+          </a:ln>
+        </p:spPr>
+      </p:sp>
+      <p:sp>
+        <p:nvSpPr>
+          <p:cNvPr id="27" name="Text 25"/>
+          <p:cNvSpPr/>
+          <p:nvPr/>
+        </p:nvSpPr>
+        <p:spPr>
+          <a:xfrm>
+            <a:off x="960120" y="3566160"/>
+            <a:ext cx="5943600" cy="365760"/>
+          </a:xfrm>
+          <a:prstGeom prst="rect">
+            <a:avLst/>
+          </a:prstGeom>
+          <a:noFill/>
+          <a:ln/>
+        </p:spPr>
+        <p:txBody>
+          <a:bodyPr wrap="square" rtlCol="0" anchor="ctr"/>
+          <a:lstStyle/>
+          <a:p>
+            <a:pPr algn="l" indent="0" marL="0">
+              <a:buNone/>
+            </a:pPr>
+            <a:r>
+              <a:rPr lang="en-US" sz="1100" dirty="0">
+                <a:solidFill>
+                  <a:srgbClr val="2C2C2A"/>
+                </a:solidFill>
+                <a:latin typeface="Inter" pitchFamily="34" charset="0"/>
+                <a:ea typeface="Inter" pitchFamily="34" charset="-122"/>
+                <a:cs typeface="Inter" pitchFamily="34" charset="-120"/>
+              </a:rPr>
+              <a:t>Closed-loop quality</a:t>
+            </a:r>
+            <a:endParaRPr lang="en-US" sz="1100" dirty="0"/>
+          </a:p>
+        </p:txBody>
+      </p:sp>
+      <p:sp>
+        <p:nvSpPr>
+          <p:cNvPr id="28" name="Text 26"/>
+          <p:cNvSpPr/>
+          <p:nvPr/>
+        </p:nvSpPr>
+        <p:spPr>
+          <a:xfrm>
+            <a:off x="6949440" y="3566160"/>
+            <a:ext cx="1645920" cy="365760"/>
+          </a:xfrm>
+          <a:prstGeom prst="rect">
+            <a:avLst/>
+          </a:prstGeom>
+          <a:noFill/>
+          <a:ln/>
+        </p:spPr>
+        <p:txBody>
+          <a:bodyPr wrap="square" rtlCol="0" anchor="ctr"/>
+          <a:lstStyle/>
+          <a:p>
+            <a:pPr algn="r" indent="0" marL="0">
+              <a:buNone/>
+            </a:pPr>
+            <a:r>
+              <a:rPr lang="en-US" sz="900" i="1" dirty="0">
+                <a:solidFill>
+                  <a:srgbClr val="2C2C2A"/>
+                </a:solidFill>
+                <a:latin typeface="Inter" pitchFamily="34" charset="0"/>
+                <a:ea typeface="Inter" pitchFamily="34" charset="-122"/>
+                <a:cs typeface="Inter" pitchFamily="34" charset="-120"/>
+              </a:rPr>
+              <a:t>wysoki</a:t>
+            </a:r>
+            <a:endParaRPr lang="en-US" sz="900" dirty="0"/>
+          </a:p>
+        </p:txBody>
+      </p:sp>
+      <p:sp>
+        <p:nvSpPr>
+          <p:cNvPr id="29" name="Shape 27"/>
+          <p:cNvSpPr/>
+          <p:nvPr/>
+        </p:nvSpPr>
+        <p:spPr>
+          <a:xfrm>
+            <a:off x="548640" y="3977640"/>
+            <a:ext cx="310896" cy="310896"/>
+          </a:xfrm>
+          <a:prstGeom prst="ellipse">
+            <a:avLst/>
+          </a:prstGeom>
+          <a:solidFill>
+            <a:srgbClr val="FFFFFF"/>
+          </a:solidFill>
+          <a:ln w="12700">
+            <a:solidFill>
+              <a:srgbClr val="1D9E75"/>
+            </a:solidFill>
+            <a:prstDash val="solid"/>
+          </a:ln>
+        </p:spPr>
+      </p:sp>
+      <p:sp>
+        <p:nvSpPr>
+          <p:cNvPr id="30" name="Shape 28"/>
+          <p:cNvSpPr/>
+          <p:nvPr/>
+        </p:nvSpPr>
+        <p:spPr>
+          <a:xfrm>
+            <a:off x="548640" y="3977640"/>
+            <a:ext cx="310896" cy="310896"/>
+          </a:xfrm>
+          <a:prstGeom prst="pie">
+            <a:avLst>
+              <a:gd name="adj1" fmla="val 0"/>
+              <a:gd name="adj2" fmla="val 16200000"/>
+            </a:avLst>
+          </a:prstGeom>
+          <a:solidFill>
+            <a:srgbClr val="1D9E75"/>
+          </a:solidFill>
+          <a:ln w="12700">
+            <a:solidFill>
+              <a:srgbClr val="1D9E75"/>
+            </a:solidFill>
+            <a:prstDash val="solid"/>
+          </a:ln>
+        </p:spPr>
+      </p:sp>
+      <p:sp>
+        <p:nvSpPr>
+          <p:cNvPr id="31" name="Text 29"/>
+          <p:cNvSpPr/>
+          <p:nvPr/>
+        </p:nvSpPr>
+        <p:spPr>
+          <a:xfrm>
+            <a:off x="960120" y="3977640"/>
+            <a:ext cx="5943600" cy="365760"/>
+          </a:xfrm>
+          <a:prstGeom prst="rect">
+            <a:avLst/>
+          </a:prstGeom>
+          <a:noFill/>
+          <a:ln/>
+        </p:spPr>
+        <p:txBody>
+          <a:bodyPr wrap="square" rtlCol="0" anchor="ctr"/>
+          <a:lstStyle/>
+          <a:p>
+            <a:pPr algn="l" indent="0" marL="0">
+              <a:buNone/>
+            </a:pPr>
+            <a:r>
+              <a:rPr lang="en-US" sz="1100" dirty="0">
+                <a:solidFill>
+                  <a:srgbClr val="2C2C2A"/>
+                </a:solidFill>
+                <a:latin typeface="Inter" pitchFamily="34" charset="0"/>
+                <a:ea typeface="Inter" pitchFamily="34" charset="-122"/>
+                <a:cs typeface="Inter" pitchFamily="34" charset="-120"/>
+              </a:rPr>
+              <a:t>OT cybersecurity</a:t>
+            </a:r>
+            <a:endParaRPr lang="en-US" sz="1100" dirty="0"/>
+          </a:p>
+        </p:txBody>
+      </p:sp>
+      <p:sp>
+        <p:nvSpPr>
+          <p:cNvPr id="32" name="Text 30"/>
+          <p:cNvSpPr/>
+          <p:nvPr/>
+        </p:nvSpPr>
+        <p:spPr>
+          <a:xfrm>
+            <a:off x="6949440" y="3977640"/>
+            <a:ext cx="1645920" cy="365760"/>
+          </a:xfrm>
+          <a:prstGeom prst="rect">
+            <a:avLst/>
+          </a:prstGeom>
+          <a:noFill/>
+          <a:ln/>
+        </p:spPr>
+        <p:txBody>
+          <a:bodyPr wrap="square" rtlCol="0" anchor="ctr"/>
+          <a:lstStyle/>
+          <a:p>
+            <a:pPr algn="r" indent="0" marL="0">
+              <a:buNone/>
+            </a:pPr>
+            <a:r>
+              <a:rPr lang="en-US" sz="900" i="1" dirty="0">
+                <a:solidFill>
+                  <a:srgbClr val="2C2C2A"/>
+                </a:solidFill>
+                <a:latin typeface="Inter" pitchFamily="34" charset="0"/>
+                <a:ea typeface="Inter" pitchFamily="34" charset="-122"/>
+                <a:cs typeface="Inter" pitchFamily="34" charset="-120"/>
+              </a:rPr>
+              <a:t>wysoki</a:t>
+            </a:r>
+            <a:endParaRPr lang="en-US" sz="900" dirty="0"/>
+          </a:p>
+        </p:txBody>
+      </p:sp>
+      <p:sp>
+        <p:nvSpPr>
+          <p:cNvPr id="33" name="Shape 31"/>
+          <p:cNvSpPr/>
+          <p:nvPr/>
+        </p:nvSpPr>
+        <p:spPr>
+          <a:xfrm>
+            <a:off x="548640" y="4389120"/>
+            <a:ext cx="310896" cy="310896"/>
+          </a:xfrm>
+          <a:prstGeom prst="ellipse">
+            <a:avLst/>
+          </a:prstGeom>
+          <a:solidFill>
+            <a:srgbClr val="FFFFFF"/>
+          </a:solidFill>
+          <a:ln w="12700">
+            <a:solidFill>
+              <a:srgbClr val="1D9E75"/>
+            </a:solidFill>
+            <a:prstDash val="solid"/>
+          </a:ln>
+        </p:spPr>
+      </p:sp>
+      <p:sp>
+        <p:nvSpPr>
+          <p:cNvPr id="34" name="Shape 32"/>
+          <p:cNvSpPr/>
+          <p:nvPr/>
+        </p:nvSpPr>
+        <p:spPr>
+          <a:xfrm>
+            <a:off x="548640" y="4389120"/>
+            <a:ext cx="310896" cy="310896"/>
+          </a:xfrm>
+          <a:prstGeom prst="pie">
+            <a:avLst>
+              <a:gd name="adj1" fmla="val 0"/>
+              <a:gd name="adj2" fmla="val 10800000"/>
+            </a:avLst>
+          </a:prstGeom>
+          <a:solidFill>
+            <a:srgbClr val="1D9E75"/>
+          </a:solidFill>
+          <a:ln w="12700">
+            <a:solidFill>
+              <a:srgbClr val="1D9E75"/>
+            </a:solidFill>
+            <a:prstDash val="solid"/>
+          </a:ln>
+        </p:spPr>
+      </p:sp>
+      <p:sp>
+        <p:nvSpPr>
+          <p:cNvPr id="35" name="Text 33"/>
+          <p:cNvSpPr/>
+          <p:nvPr/>
+        </p:nvSpPr>
+        <p:spPr>
+          <a:xfrm>
+            <a:off x="960120" y="4389120"/>
+            <a:ext cx="5943600" cy="365760"/>
+          </a:xfrm>
+          <a:prstGeom prst="rect">
+            <a:avLst/>
+          </a:prstGeom>
+          <a:noFill/>
+          <a:ln/>
+        </p:spPr>
+        <p:txBody>
+          <a:bodyPr wrap="square" rtlCol="0" anchor="ctr"/>
+          <a:lstStyle/>
+          <a:p>
+            <a:pPr algn="l" indent="0" marL="0">
+              <a:buNone/>
+            </a:pPr>
+            <a:r>
+              <a:rPr lang="en-US" sz="1100" dirty="0">
+                <a:solidFill>
+                  <a:srgbClr val="2C2C2A"/>
+                </a:solidFill>
+                <a:latin typeface="Inter" pitchFamily="34" charset="0"/>
+                <a:ea typeface="Inter" pitchFamily="34" charset="-122"/>
+                <a:cs typeface="Inter" pitchFamily="34" charset="-120"/>
+              </a:rPr>
+              <a:t>Partner activation</a:t>
+            </a:r>
+            <a:endParaRPr lang="en-US" sz="1100" dirty="0"/>
+          </a:p>
+        </p:txBody>
+      </p:sp>
+      <p:sp>
+        <p:nvSpPr>
+          <p:cNvPr id="36" name="Text 34"/>
+          <p:cNvSpPr/>
+          <p:nvPr/>
+        </p:nvSpPr>
+        <p:spPr>
+          <a:xfrm>
+            <a:off x="6949440" y="4389120"/>
+            <a:ext cx="1645920" cy="365760"/>
+          </a:xfrm>
+          <a:prstGeom prst="rect">
+            <a:avLst/>
+          </a:prstGeom>
+          <a:noFill/>
+          <a:ln/>
+        </p:spPr>
+        <p:txBody>
+          <a:bodyPr wrap="square" rtlCol="0" anchor="ctr"/>
+          <a:lstStyle/>
+          <a:p>
+            <a:pPr algn="r" indent="0" marL="0">
+              <a:buNone/>
+            </a:pPr>
+            <a:r>
+              <a:rPr lang="en-US" sz="900" i="1" dirty="0">
+                <a:solidFill>
+                  <a:srgbClr val="2C2C2A"/>
+                </a:solidFill>
+                <a:latin typeface="Inter" pitchFamily="34" charset="0"/>
+                <a:ea typeface="Inter" pitchFamily="34" charset="-122"/>
+                <a:cs typeface="Inter" pitchFamily="34" charset="-120"/>
+              </a:rPr>
+              <a:t>średni</a:t>
+            </a:r>
+            <a:endParaRPr lang="en-US" sz="900" dirty="0"/>
+          </a:p>
+        </p:txBody>
+      </p:sp>
+      <p:sp>
+        <p:nvSpPr>
+          <p:cNvPr id="37" name="Text 35"/>
+          <p:cNvSpPr/>
+          <p:nvPr/>
+        </p:nvSpPr>
+        <p:spPr>
+          <a:xfrm>
+            <a:off x="548640" y="1463040"/>
+            <a:ext cx="8046720" cy="411480"/>
+          </a:xfrm>
+          <a:prstGeom prst="rect">
+            <a:avLst/>
+          </a:prstGeom>
+          <a:noFill/>
+          <a:ln/>
+        </p:spPr>
+        <p:txBody>
+          <a:bodyPr wrap="square" rtlCol="0" anchor="t"/>
+          <a:lstStyle/>
+          <a:p>
+            <a:pPr algn="l" indent="0" marL="0">
+              <a:buNone/>
+            </a:pPr>
+            <a:r>
+              <a:rPr lang="en-US" sz="1100" dirty="0">
+                <a:solidFill>
+                  <a:srgbClr val="2C2C2A"/>
+                </a:solidFill>
+                <a:latin typeface="Inter" pitchFamily="34" charset="0"/>
+                <a:ea typeface="Inter" pitchFamily="34" charset="-122"/>
+                <a:cs typeface="Inter" pitchFamily="34" charset="-120"/>
+              </a:rPr>
+              <a:t>Start where evidence is strong, the value pool is material, and named owners already exist — do not wait for a perfect maturity audit before launching the first wave.</a:t>
+            </a:r>
+            <a:endParaRPr lang="en-US" sz="1100" dirty="0"/>
           </a:p>
         </p:txBody>
       </p:sp>
@@ -6696,7 +8168,7 @@
                 <a:ea typeface="Merriweather" pitchFamily="34" charset="-122"/>
                 <a:cs typeface="Merriweather" pitchFamily="34" charset="-120"/>
               </a:rPr>
-              <a:t>Atelier Digital renewal risk is detected too late to cure, only to negotiate</a:t>
+              <a:t>Factory telemetry is rich, but supervisors react 30 minutes after the loss</a:t>
             </a:r>
             <a:endParaRPr lang="en-US" sz="3000" dirty="0"/>
           </a:p>
@@ -6871,14 +8343,81 @@
       </p:sp>
       <p:sp>
         <p:nvSpPr>
-          <p:cNvPr id="9" name="Text 7"/>
-          <p:cNvSpPr/>
-          <p:nvPr/>
-        </p:nvSpPr>
-        <p:spPr>
-          <a:xfrm>
-            <a:off x="548640" y="1554480"/>
-            <a:ext cx="8046720" cy="3017520"/>
+          <p:cNvPr id="9" name="Shape 7"/>
+          <p:cNvSpPr/>
+          <p:nvPr/>
+        </p:nvSpPr>
+        <p:spPr>
+          <a:xfrm>
+            <a:off x="548640" y="1600200"/>
+            <a:ext cx="73152" cy="822960"/>
+          </a:xfrm>
+          <a:prstGeom prst="rect">
+            <a:avLst/>
+          </a:prstGeom>
+          <a:solidFill>
+            <a:srgbClr val="1D9E75"/>
+          </a:solidFill>
+          <a:ln w="12700">
+            <a:solidFill>
+              <a:srgbClr val="1D9E75"/>
+            </a:solidFill>
+            <a:prstDash val="solid"/>
+          </a:ln>
+        </p:spPr>
+      </p:sp>
+      <p:sp>
+        <p:nvSpPr>
+          <p:cNvPr id="10" name="Text 8"/>
+          <p:cNvSpPr/>
+          <p:nvPr/>
+        </p:nvSpPr>
+        <p:spPr>
+          <a:xfrm>
+            <a:off x="749808" y="1554480"/>
+            <a:ext cx="3977640" cy="3063240"/>
+          </a:xfrm>
+          <a:prstGeom prst="rect">
+            <a:avLst/>
+          </a:prstGeom>
+          <a:noFill/>
+          <a:ln/>
+        </p:spPr>
+        <p:txBody>
+          <a:bodyPr wrap="square" rtlCol="0" anchor="t"/>
+          <a:lstStyle/>
+          <a:p>
+            <a:pPr algn="l" indent="0" marL="0">
+              <a:lnSpc>
+                <a:spcPct val="102000"/>
+              </a:lnSpc>
+              <a:buNone/>
+            </a:pPr>
+            <a:r>
+              <a:rPr lang="en-US" sz="2400" b="1" dirty="0">
+                <a:solidFill>
+                  <a:srgbClr val="0C447C"/>
+                </a:solidFill>
+                <a:latin typeface="Merriweather" pitchFamily="34" charset="0"/>
+                <a:ea typeface="Merriweather" pitchFamily="34" charset="-122"/>
+                <a:cs typeface="Merriweather" pitchFamily="34" charset="-120"/>
+              </a:rPr>
+              <a:t>Alerts exist; routing, classification and action protocols are inconsistent across shifts — a 20–30 minute event-to-response lag leaks 0.8–1.2 M EUR/yr on Line 3.</a:t>
+            </a:r>
+            <a:endParaRPr lang="en-US" sz="2400" dirty="0"/>
+          </a:p>
+        </p:txBody>
+      </p:sp>
+      <p:sp>
+        <p:nvSpPr>
+          <p:cNvPr id="11" name="Text 9"/>
+          <p:cNvSpPr/>
+          <p:nvPr/>
+        </p:nvSpPr>
+        <p:spPr>
+          <a:xfrm>
+            <a:off x="5212080" y="1554480"/>
+            <a:ext cx="3383280" cy="3063240"/>
           </a:xfrm>
           <a:prstGeom prst="rect">
             <a:avLst/>
@@ -6892,7 +8431,7 @@
           </a:bodyPr>
           <a:lstStyle/>
           <a:p>
-            <a:pPr algn="l" marL="228600" indent="-228600">
+            <a:pPr algn="l" marL="203200" indent="-203200">
               <a:spcAft>
                 <a:spcPts val="800"/>
               </a:spcAft>
@@ -6900,7 +8439,7 @@
               <a:buChar char="▪"/>
             </a:pPr>
             <a:r>
-              <a:rPr lang="en-US" sz="2000" dirty="0">
+              <a:rPr lang="en-US" sz="1700" dirty="0">
                 <a:solidFill>
                   <a:srgbClr val="2C2C2A"/>
                 </a:solidFill>
@@ -6908,9 +8447,9 @@
                 <a:ea typeface="Inter" pitchFamily="34" charset="-122"/>
                 <a:cs typeface="Inter" pitchFamily="34" charset="-120"/>
               </a:rPr>
-              <a:t>Decision required: launch a renewal-risk action system</a:t>
-            </a:r>
-            <a:pPr algn="l" marL="228600" indent="-228600">
+              <a:t>Decision required: approve a Line 3 shift-decision contract</a:t>
+            </a:r>
+            <a:pPr algn="l" marL="203200" indent="-203200">
               <a:spcAft>
                 <a:spcPts val="800"/>
               </a:spcAft>
@@ -6918,7 +8457,7 @@
               <a:buChar char="▪"/>
             </a:pPr>
             <a:r>
-              <a:rPr lang="en-US" sz="2000" dirty="0">
+              <a:rPr lang="en-US" sz="1700" dirty="0">
                 <a:solidFill>
                   <a:srgbClr val="2C2C2A"/>
                 </a:solidFill>
@@ -6926,9 +8465,9 @@
                 <a:ea typeface="Inter" pitchFamily="34" charset="-122"/>
                 <a:cs typeface="Inter" pitchFamily="34" charset="-120"/>
               </a:rPr>
-              <a:t>Fuse usage, support, partner and account signals weekly</a:t>
-            </a:r>
-            <a:pPr algn="l" marL="228600" indent="-228600">
+              <a:t>Event taxonomy + alert routing + action protocol + learning capture</a:t>
+            </a:r>
+            <a:pPr algn="l" marL="203200" indent="-203200">
               <a:spcAft>
                 <a:spcPts val="800"/>
               </a:spcAft>
@@ -6936,7 +8475,7 @@
               <a:buChar char="▪"/>
             </a:pPr>
             <a:r>
-              <a:rPr lang="en-US" sz="2000" dirty="0">
+              <a:rPr lang="en-US" sz="1700" dirty="0">
                 <a:solidFill>
                   <a:srgbClr val="2C2C2A"/>
                 </a:solidFill>
@@ -6944,9 +8483,9 @@
                 <a:ea typeface="Inter" pitchFamily="34" charset="-122"/>
                 <a:cs typeface="Inter" pitchFamily="34" charset="-120"/>
               </a:rPr>
-              <a:t>Ship prioritized intervention list with owners and playbooks</a:t>
-            </a:r>
-            <a:pPr algn="l" marL="228600" indent="-228600">
+              <a:t>Fund Digital Twin as an operating system, not a dashboard</a:t>
+            </a:r>
+            <a:pPr algn="l" marL="203200" indent="-203200">
               <a:spcAft>
                 <a:spcPts val="800"/>
               </a:spcAft>
@@ -6954,7 +8493,7 @@
               <a:buChar char="▪"/>
             </a:pPr>
             <a:r>
-              <a:rPr lang="en-US" sz="2000" dirty="0">
+              <a:rPr lang="en-US" sz="1700" dirty="0">
                 <a:solidFill>
                   <a:srgbClr val="2C2C2A"/>
                 </a:solidFill>
@@ -6962,9 +8501,9 @@
                 <a:ea typeface="Inter" pitchFamily="34" charset="-122"/>
                 <a:cs typeface="Inter" pitchFamily="34" charset="-120"/>
               </a:rPr>
-              <a:t>Not another analytics dashboard — an action system</a:t>
-            </a:r>
-            <a:endParaRPr lang="en-US" sz="2000" dirty="0"/>
+              <a:t>Adoption KPIs sit next to outcome KPIs</a:t>
+            </a:r>
+            <a:endParaRPr lang="en-US" sz="1700" dirty="0"/>
           </a:p>
         </p:txBody>
       </p:sp>
@@ -7063,7 +8602,7 @@
                 <a:ea typeface="Merriweather" pitchFamily="34" charset="-122"/>
                 <a:cs typeface="Merriweather" pitchFamily="34" charset="-120"/>
               </a:rPr>
-              <a:t>Data governance is the common dependency under nearly every value pool</a:t>
+              <a:t>Atelier Digital renewal risk is detected too late to cure, only to negotiate</a:t>
             </a:r>
             <a:endParaRPr lang="en-US" sz="3000" dirty="0"/>
           </a:p>
@@ -7238,14 +8777,81 @@
       </p:sp>
       <p:sp>
         <p:nvSpPr>
-          <p:cNvPr id="9" name="Text 7"/>
-          <p:cNvSpPr/>
-          <p:nvPr/>
-        </p:nvSpPr>
-        <p:spPr>
-          <a:xfrm>
-            <a:off x="548640" y="1554480"/>
-            <a:ext cx="8046720" cy="3017520"/>
+          <p:cNvPr id="9" name="Shape 7"/>
+          <p:cNvSpPr/>
+          <p:nvPr/>
+        </p:nvSpPr>
+        <p:spPr>
+          <a:xfrm>
+            <a:off x="548640" y="1600200"/>
+            <a:ext cx="73152" cy="822960"/>
+          </a:xfrm>
+          <a:prstGeom prst="rect">
+            <a:avLst/>
+          </a:prstGeom>
+          <a:solidFill>
+            <a:srgbClr val="1D9E75"/>
+          </a:solidFill>
+          <a:ln w="12700">
+            <a:solidFill>
+              <a:srgbClr val="1D9E75"/>
+            </a:solidFill>
+            <a:prstDash val="solid"/>
+          </a:ln>
+        </p:spPr>
+      </p:sp>
+      <p:sp>
+        <p:nvSpPr>
+          <p:cNvPr id="10" name="Text 8"/>
+          <p:cNvSpPr/>
+          <p:nvPr/>
+        </p:nvSpPr>
+        <p:spPr>
+          <a:xfrm>
+            <a:off x="749808" y="1554480"/>
+            <a:ext cx="3977640" cy="3063240"/>
+          </a:xfrm>
+          <a:prstGeom prst="rect">
+            <a:avLst/>
+          </a:prstGeom>
+          <a:noFill/>
+          <a:ln/>
+        </p:spPr>
+        <p:txBody>
+          <a:bodyPr wrap="square" rtlCol="0" anchor="t"/>
+          <a:lstStyle/>
+          <a:p>
+            <a:pPr algn="l" indent="0" marL="0">
+              <a:lnSpc>
+                <a:spcPct val="102000"/>
+              </a:lnSpc>
+              <a:buNone/>
+            </a:pPr>
+            <a:r>
+              <a:rPr lang="en-US" sz="2300" b="1" dirty="0">
+                <a:solidFill>
+                  <a:srgbClr val="0C447C"/>
+                </a:solidFill>
+                <a:latin typeface="Merriweather" pitchFamily="34" charset="0"/>
+                <a:ea typeface="Merriweather" pitchFamily="34" charset="-122"/>
+                <a:cs typeface="Merriweather" pitchFamily="34" charset="-120"/>
+              </a:rPr>
+              <a:t>Activation, usage, support and partner signals live in separate views; risk surfaces only after escalation. Moving gross renewal from 76-80% toward the 88-92% top-quartile reference protects 4-6 M EUR ARR.</a:t>
+            </a:r>
+            <a:endParaRPr lang="en-US" sz="2300" dirty="0"/>
+          </a:p>
+        </p:txBody>
+      </p:sp>
+      <p:sp>
+        <p:nvSpPr>
+          <p:cNvPr id="11" name="Text 9"/>
+          <p:cNvSpPr/>
+          <p:nvPr/>
+        </p:nvSpPr>
+        <p:spPr>
+          <a:xfrm>
+            <a:off x="5212080" y="1554480"/>
+            <a:ext cx="3383280" cy="3063240"/>
           </a:xfrm>
           <a:prstGeom prst="rect">
             <a:avLst/>
@@ -7259,7 +8865,7 @@
           </a:bodyPr>
           <a:lstStyle/>
           <a:p>
-            <a:pPr algn="l" marL="228600" indent="-228600">
+            <a:pPr algn="l" marL="203200" indent="-203200">
               <a:spcAft>
                 <a:spcPts val="800"/>
               </a:spcAft>
@@ -7267,7 +8873,7 @@
               <a:buChar char="▪"/>
             </a:pPr>
             <a:r>
-              <a:rPr lang="en-US" sz="2000" dirty="0">
+              <a:rPr lang="en-US" sz="1700" dirty="0">
                 <a:solidFill>
                   <a:srgbClr val="2C2C2A"/>
                 </a:solidFill>
@@ -7275,9 +8881,9 @@
                 <a:ea typeface="Inter" pitchFamily="34" charset="-122"/>
                 <a:cs typeface="Inter" pitchFamily="34" charset="-120"/>
               </a:rPr>
-              <a:t>Decision required: fund top-25 metric ownership and lineage…</a:t>
-            </a:r>
-            <a:pPr algn="l" marL="228600" indent="-228600">
+              <a:t>Decision required: launch a renewal-risk action system</a:t>
+            </a:r>
+            <a:pPr algn="l" marL="203200" indent="-203200">
               <a:spcAft>
                 <a:spcPts val="800"/>
               </a:spcAft>
@@ -7285,7 +8891,7 @@
               <a:buChar char="▪"/>
             </a:pPr>
             <a:r>
-              <a:rPr lang="en-US" sz="2000" dirty="0">
+              <a:rPr lang="en-US" sz="1700" dirty="0">
                 <a:solidFill>
                   <a:srgbClr val="2C2C2A"/>
                 </a:solidFill>
@@ -7293,9 +8899,9 @@
                 <a:ea typeface="Inter" pitchFamily="34" charset="-122"/>
                 <a:cs typeface="Inter" pitchFamily="34" charset="-120"/>
               </a:rPr>
-              <a:t>Treat data governance as enabling infrastructure, not back-office</a:t>
-            </a:r>
-            <a:pPr algn="l" marL="228600" indent="-228600">
+              <a:t>Fuse usage, support, partner and account signals weekly</a:t>
+            </a:r>
+            <a:pPr algn="l" marL="203200" indent="-203200">
               <a:spcAft>
                 <a:spcPts val="800"/>
               </a:spcAft>
@@ -7303,7 +8909,7 @@
               <a:buChar char="▪"/>
             </a:pPr>
             <a:r>
-              <a:rPr lang="en-US" sz="2000" dirty="0">
+              <a:rPr lang="en-US" sz="1700" dirty="0">
                 <a:solidFill>
                   <a:srgbClr val="2C2C2A"/>
                 </a:solidFill>
@@ -7311,9 +8917,9 @@
                 <a:ea typeface="Inter" pitchFamily="34" charset="-122"/>
                 <a:cs typeface="Inter" pitchFamily="34" charset="-120"/>
               </a:rPr>
-              <a:t>Definitions, ownership, lineage, quality SLAs — the boring…</a:t>
-            </a:r>
-            <a:pPr algn="l" marL="228600" indent="-228600">
+              <a:t>Ship prioritized intervention list with owners and playbooks</a:t>
+            </a:r>
+            <a:pPr algn="l" marL="203200" indent="-203200">
               <a:spcAft>
                 <a:spcPts val="800"/>
               </a:spcAft>
@@ -7321,7 +8927,7 @@
               <a:buChar char="▪"/>
             </a:pPr>
             <a:r>
-              <a:rPr lang="en-US" sz="2000" dirty="0">
+              <a:rPr lang="en-US" sz="1700" dirty="0">
                 <a:solidFill>
                   <a:srgbClr val="2C2C2A"/>
                 </a:solidFill>
@@ -7329,9 +8935,9 @@
                 <a:ea typeface="Inter" pitchFamily="34" charset="-122"/>
                 <a:cs typeface="Inter" pitchFamily="34" charset="-120"/>
               </a:rPr>
-              <a:t>Prerequisite for COPPA / FERPA-aligned US readiness</a:t>
-            </a:r>
-            <a:endParaRPr lang="en-US" sz="2000" dirty="0"/>
+              <a:t>Not another analytics dashboard — an action system</a:t>
+            </a:r>
+            <a:endParaRPr lang="en-US" sz="1700" dirty="0"/>
           </a:p>
         </p:txBody>
       </p:sp>
@@ -7430,7 +9036,7 @@
                 <a:ea typeface="Merriweather" pitchFamily="34" charset="-122"/>
                 <a:cs typeface="Merriweather" pitchFamily="34" charset="-120"/>
               </a:rPr>
-              <a:t>US expansion raises the bar: data, AI, partner and tariff readiness need evidence</a:t>
+              <a:t>Data governance is the common dependency under nearly every value pool</a:t>
             </a:r>
             <a:endParaRPr lang="en-US" sz="3000" dirty="0"/>
           </a:p>
@@ -7597,7 +9203,7 @@
                 <a:ea typeface="Inter" pitchFamily="34" charset="-122"/>
                 <a:cs typeface="Inter" pitchFamily="34" charset="-120"/>
               </a:rPr>
-              <a:t>MARKET</a:t>
+              <a:t>SOLUTION</a:t>
             </a:r>
             <a:endParaRPr lang="en-US" sz="700" dirty="0"/>
           </a:p>
@@ -7605,14 +9211,81 @@
       </p:sp>
       <p:sp>
         <p:nvSpPr>
-          <p:cNvPr id="9" name="Text 7"/>
-          <p:cNvSpPr/>
-          <p:nvPr/>
-        </p:nvSpPr>
-        <p:spPr>
-          <a:xfrm>
-            <a:off x="548640" y="1554480"/>
-            <a:ext cx="8046720" cy="3017520"/>
+          <p:cNvPr id="9" name="Shape 7"/>
+          <p:cNvSpPr/>
+          <p:nvPr/>
+        </p:nvSpPr>
+        <p:spPr>
+          <a:xfrm>
+            <a:off x="548640" y="1600200"/>
+            <a:ext cx="73152" cy="822960"/>
+          </a:xfrm>
+          <a:prstGeom prst="rect">
+            <a:avLst/>
+          </a:prstGeom>
+          <a:solidFill>
+            <a:srgbClr val="1D9E75"/>
+          </a:solidFill>
+          <a:ln w="12700">
+            <a:solidFill>
+              <a:srgbClr val="1D9E75"/>
+            </a:solidFill>
+            <a:prstDash val="solid"/>
+          </a:ln>
+        </p:spPr>
+      </p:sp>
+      <p:sp>
+        <p:nvSpPr>
+          <p:cNvPr id="10" name="Text 8"/>
+          <p:cNvSpPr/>
+          <p:nvPr/>
+        </p:nvSpPr>
+        <p:spPr>
+          <a:xfrm>
+            <a:off x="749808" y="1554480"/>
+            <a:ext cx="3977640" cy="3063240"/>
+          </a:xfrm>
+          <a:prstGeom prst="rect">
+            <a:avLst/>
+          </a:prstGeom>
+          <a:noFill/>
+          <a:ln/>
+        </p:spPr>
+        <p:txBody>
+          <a:bodyPr wrap="square" rtlCol="0" anchor="t"/>
+          <a:lstStyle/>
+          <a:p>
+            <a:pPr algn="l" indent="0" marL="0">
+              <a:lnSpc>
+                <a:spcPct val="102000"/>
+              </a:lnSpc>
+              <a:buNone/>
+            </a:pPr>
+            <a:r>
+              <a:rPr lang="en-US" sz="2100" b="1" dirty="0">
+                <a:solidFill>
+                  <a:srgbClr val="0C447C"/>
+                </a:solidFill>
+                <a:latin typeface="Merriweather" pitchFamily="34" charset="0"/>
+                <a:ea typeface="Merriweather" pitchFamily="34" charset="-122"/>
+                <a:cs typeface="Merriweather" pitchFamily="34" charset="-120"/>
+              </a:rPr>
+              <a:t>OEE, defect recurrence, supplier risk, renewal risk, partner activation and roadmap value all need one source of truth. Inconsistent definitions drag portfolio productivity 8-12% and raise US audit cost as scale grows.</a:t>
+            </a:r>
+            <a:endParaRPr lang="en-US" sz="2100" dirty="0"/>
+          </a:p>
+        </p:txBody>
+      </p:sp>
+      <p:sp>
+        <p:nvSpPr>
+          <p:cNvPr id="11" name="Text 9"/>
+          <p:cNvSpPr/>
+          <p:nvPr/>
+        </p:nvSpPr>
+        <p:spPr>
+          <a:xfrm>
+            <a:off x="5212080" y="1554480"/>
+            <a:ext cx="3383280" cy="3063240"/>
           </a:xfrm>
           <a:prstGeom prst="rect">
             <a:avLst/>
@@ -7626,7 +9299,7 @@
           </a:bodyPr>
           <a:lstStyle/>
           <a:p>
-            <a:pPr algn="l" marL="228600" indent="-228600">
+            <a:pPr algn="l" marL="203200" indent="-203200">
               <a:spcAft>
                 <a:spcPts val="800"/>
               </a:spcAft>
@@ -7634,7 +9307,7 @@
               <a:buChar char="▪"/>
             </a:pPr>
             <a:r>
-              <a:rPr lang="en-US" sz="2000" dirty="0">
+              <a:rPr lang="en-US" sz="1700" dirty="0">
                 <a:solidFill>
                   <a:srgbClr val="2C2C2A"/>
                 </a:solidFill>
@@ -7642,9 +9315,9 @@
                 <a:ea typeface="Inter" pitchFamily="34" charset="-122"/>
                 <a:cs typeface="Inter" pitchFamily="34" charset="-120"/>
               </a:rPr>
-              <a:t>District &amp; GPO contract readiness — Partial, close…</a:t>
-            </a:r>
-            <a:pPr algn="l" marL="228600" indent="-228600">
+              <a:t>Decision required: fund top-25 metric ownership and lineage in Wave 1</a:t>
+            </a:r>
+            <a:pPr algn="l" marL="203200" indent="-203200">
               <a:spcAft>
                 <a:spcPts val="800"/>
               </a:spcAft>
@@ -7652,7 +9325,7 @@
               <a:buChar char="▪"/>
             </a:pPr>
             <a:r>
-              <a:rPr lang="en-US" sz="2000" dirty="0">
+              <a:rPr lang="en-US" sz="1700" dirty="0">
                 <a:solidFill>
                   <a:srgbClr val="2C2C2A"/>
                 </a:solidFill>
@@ -7660,9 +9333,9 @@
                 <a:ea typeface="Inter" pitchFamily="34" charset="-122"/>
                 <a:cs typeface="Inter" pitchFamily="34" charset="-120"/>
               </a:rPr>
-              <a:t>COPPA / US state privacy posture — Needs…</a:t>
-            </a:r>
-            <a:pPr algn="l" marL="228600" indent="-228600">
+              <a:t>Treat data governance as enabling infrastructure, not back-office</a:t>
+            </a:r>
+            <a:pPr algn="l" marL="203200" indent="-203200">
               <a:spcAft>
                 <a:spcPts val="800"/>
               </a:spcAft>
@@ -7670,7 +9343,7 @@
               <a:buChar char="▪"/>
             </a:pPr>
             <a:r>
-              <a:rPr lang="en-US" sz="2000" dirty="0">
+              <a:rPr lang="en-US" sz="1700" dirty="0">
                 <a:solidFill>
                   <a:srgbClr val="2C2C2A"/>
                 </a:solidFill>
@@ -7678,9 +9351,9 @@
                 <a:ea typeface="Inter" pitchFamily="34" charset="-122"/>
                 <a:cs typeface="Inter" pitchFamily="34" charset="-120"/>
               </a:rPr>
-              <a:t>AI use-case governance for child-facing AI — Needs…</a:t>
-            </a:r>
-            <a:pPr algn="l" marL="228600" indent="-228600">
+              <a:t>Definitions, ownership, lineage, quality SLAs — the boring work</a:t>
+            </a:r>
+            <a:pPr algn="l" marL="203200" indent="-203200">
               <a:spcAft>
                 <a:spcPts val="800"/>
               </a:spcAft>
@@ -7688,7 +9361,7 @@
               <a:buChar char="▪"/>
             </a:pPr>
             <a:r>
-              <a:rPr lang="en-US" sz="2000" dirty="0">
+              <a:rPr lang="en-US" sz="1700" dirty="0">
                 <a:solidFill>
                   <a:srgbClr val="2C2C2A"/>
                 </a:solidFill>
@@ -7696,27 +9369,9 @@
                 <a:ea typeface="Inter" pitchFamily="34" charset="-122"/>
                 <a:cs typeface="Inter" pitchFamily="34" charset="-120"/>
               </a:rPr>
-              <a:t>Tariff &amp; origin-aware procurement — Needs evidence</a:t>
-            </a:r>
-            <a:pPr algn="l" marL="228600" indent="-228600">
-              <a:spcAft>
-                <a:spcPts val="800"/>
-              </a:spcAft>
-              <a:buSzPct val="100000"/>
-              <a:buChar char="▪"/>
-            </a:pPr>
-            <a:r>
-              <a:rPr lang="en-US" sz="2000" dirty="0">
-                <a:solidFill>
-                  <a:srgbClr val="2C2C2A"/>
-                </a:solidFill>
-                <a:latin typeface="Inter" pitchFamily="34" charset="0"/>
-                <a:ea typeface="Inter" pitchFamily="34" charset="-122"/>
-                <a:cs typeface="Inter" pitchFamily="34" charset="-120"/>
-              </a:rPr>
-              <a:t>ESG &amp; supply-chain traceability — Yes, package as…</a:t>
-            </a:r>
-            <a:endParaRPr lang="en-US" sz="2000" dirty="0"/>
+              <a:t>Prerequisite for COPPA / FERPA-aligned US readiness</a:t>
+            </a:r>
+            <a:endParaRPr lang="en-US" sz="1700" dirty="0"/>
           </a:p>
         </p:txBody>
       </p:sp>

</xml_diff>